<commit_message>
docs: update townhall presentation
</commit_message>
<xml_diff>
--- a/B2B_Sales_Agent_Townhall.pptx
+++ b/B2B_Sales_Agent_Townhall.pptx
@@ -16,8 +16,8 @@
     <p:sldId id="261" r:id="rId7"/>
     <p:sldId id="262" r:id="rId8"/>
     <p:sldId id="263" r:id="rId9"/>
-    <p:sldId id="264" r:id="rId10"/>
-    <p:sldId id="265" r:id="rId11"/>
+    <p:sldId id="265" r:id="rId10"/>
+    <p:sldId id="264" r:id="rId11"/>
     <p:sldId id="266" r:id="rId12"/>
     <p:sldId id="267" r:id="rId13"/>
   </p:sldIdLst>
@@ -2330,11 +2330,11 @@
 
 <file path=ppt/slides/slide10.xml><?xml version="1.0" encoding="utf-8"?>
 <p:sld xmlns:a="http://schemas.openxmlformats.org/drawingml/2006/main" xmlns:r="http://schemas.openxmlformats.org/officeDocument/2006/relationships" xmlns:p="http://schemas.openxmlformats.org/presentationml/2006/main">
-  <p:cSld name="Slide 10">
+  <p:cSld name="Slide 9">
     <p:bg>
       <p:bgPr>
         <a:solidFill>
-          <a:srgbClr val="F0F6FA"/>
+          <a:srgbClr val="0D1B3E"/>
         </a:solidFill>
         <a:effectLst/>
       </p:bgPr>
@@ -2383,7 +2383,7 @@
                   <a:srgbClr val="94A3B8"/>
                 </a:solidFill>
               </a:rPr>
-              <a:t>10</a:t>
+              <a:t>9</a:t>
             </a:r>
             <a:endParaRPr lang="en-US" sz="900" dirty="0"/>
           </a:p>
@@ -2397,7 +2397,7 @@
         </p:nvSpPr>
         <p:spPr>
           <a:xfrm>
-            <a:off x="457200" y="228600"/>
+            <a:off x="457200" y="182880"/>
             <a:ext cx="8229600" cy="457200"/>
           </a:xfrm>
           <a:prstGeom prst="rect">
@@ -2414,17 +2414,17 @@
               <a:buNone/>
             </a:pPr>
             <a:r>
-              <a:rPr lang="en-US" sz="3000" b="1" dirty="0">
-                <a:solidFill>
-                  <a:srgbClr val="1E293B"/>
-                </a:solidFill>
-                <a:latin typeface="Calibri" pitchFamily="34" charset="0"/>
-                <a:ea typeface="Calibri" pitchFamily="34" charset="-122"/>
-                <a:cs typeface="Calibri" pitchFamily="34" charset="-120"/>
-              </a:rPr>
-              <a:t>How the Code Was Written</a:t>
-            </a:r>
-            <a:endParaRPr lang="en-US" sz="3000" dirty="0"/>
+              <a:rPr lang="en-US" sz="2800" b="1" dirty="0">
+                <a:solidFill>
+                  <a:srgbClr val="FFFFFF"/>
+                </a:solidFill>
+                <a:latin typeface="Calibri" pitchFamily="34" charset="0"/>
+                <a:ea typeface="Calibri" pitchFamily="34" charset="-122"/>
+                <a:cs typeface="Calibri" pitchFamily="34" charset="-120"/>
+              </a:rPr>
+              <a:t>Research Foundation &amp; Grounding</a:t>
+            </a:r>
+            <a:endParaRPr lang="en-US" sz="2800" dirty="0"/>
           </a:p>
         </p:txBody>
       </p:sp>
@@ -2436,7 +2436,7 @@
         </p:nvSpPr>
         <p:spPr>
           <a:xfrm>
-            <a:off x="457200" y="731520"/>
+            <a:off x="457200" y="685800"/>
             <a:ext cx="8229600" cy="54864"/>
           </a:xfrm>
           <a:prstGeom prst="rect">
@@ -2464,19 +2464,19 @@
         <p:spPr>
           <a:xfrm>
             <a:off x="457200" y="914400"/>
-            <a:ext cx="4114800" cy="1188720"/>
-          </a:xfrm>
-          <a:prstGeom prst="rect">
-            <a:avLst/>
-          </a:prstGeom>
-          <a:solidFill>
-            <a:srgbClr val="FFFFFF"/>
+            <a:ext cx="2011680" cy="3931920"/>
+          </a:xfrm>
+          <a:prstGeom prst="rect">
+            <a:avLst/>
+          </a:prstGeom>
+          <a:solidFill>
+            <a:srgbClr val="102B5A"/>
           </a:solidFill>
           <a:ln/>
           <a:effectLst>
             <a:outerShdw blurRad="101600" dist="25400" dir="8100000" algn="bl" rotWithShape="0">
               <a:srgbClr val="000000">
-                <a:alpha val="10000"/>
+                <a:alpha val="30000"/>
               </a:srgbClr>
             </a:outerShdw>
           </a:effectLst>
@@ -2498,34 +2498,97 @@
         <p:spPr>
           <a:xfrm>
             <a:off x="457200" y="914400"/>
-            <a:ext cx="54864" cy="1188720"/>
-          </a:xfrm>
-          <a:prstGeom prst="rect">
-            <a:avLst/>
-          </a:prstGeom>
-          <a:solidFill>
-            <a:srgbClr val="00C2C7"/>
-          </a:solidFill>
-          <a:ln/>
-        </p:spPr>
-        <p:txBody>
-          <a:bodyPr/>
-          <a:lstStyle/>
-          <a:p>
-            <a:endParaRPr lang="en-US"/>
-          </a:p>
-        </p:txBody>
-      </p:sp>
-      <p:sp>
-        <p:nvSpPr>
-          <p:cNvPr id="7" name="Text 5"/>
-          <p:cNvSpPr/>
-          <p:nvPr/>
-        </p:nvSpPr>
-        <p:spPr>
-          <a:xfrm>
-            <a:off x="621792" y="987552"/>
-            <a:ext cx="457200" cy="274320"/>
+            <a:ext cx="2011680" cy="64008"/>
+          </a:xfrm>
+          <a:prstGeom prst="rect">
+            <a:avLst/>
+          </a:prstGeom>
+          <a:solidFill>
+            <a:srgbClr val="028090"/>
+          </a:solidFill>
+          <a:ln/>
+        </p:spPr>
+        <p:txBody>
+          <a:bodyPr/>
+          <a:lstStyle/>
+          <a:p>
+            <a:endParaRPr lang="en-US"/>
+          </a:p>
+        </p:txBody>
+      </p:sp>
+      <p:pic>
+        <p:nvPicPr>
+          <p:cNvPr id="7" name="Image 0" descr="preencoded.png"/>
+          <p:cNvPicPr>
+            <a:picLocks noChangeAspect="1"/>
+          </p:cNvPicPr>
+          <p:nvPr/>
+        </p:nvPicPr>
+        <p:blipFill>
+          <a:blip r:embed="rId3"/>
+          <a:stretch>
+            <a:fillRect/>
+          </a:stretch>
+        </p:blipFill>
+        <p:spPr>
+          <a:xfrm>
+            <a:off x="1188720" y="1097280"/>
+            <a:ext cx="502920" cy="502920"/>
+          </a:xfrm>
+          <a:prstGeom prst="rect">
+            <a:avLst/>
+          </a:prstGeom>
+        </p:spPr>
+      </p:pic>
+      <p:sp>
+        <p:nvSpPr>
+          <p:cNvPr id="8" name="Text 5"/>
+          <p:cNvSpPr/>
+          <p:nvPr/>
+        </p:nvSpPr>
+        <p:spPr>
+          <a:xfrm>
+            <a:off x="548640" y="1691640"/>
+            <a:ext cx="1828800" cy="365760"/>
+          </a:xfrm>
+          <a:prstGeom prst="rect">
+            <a:avLst/>
+          </a:prstGeom>
+          <a:noFill/>
+          <a:ln/>
+        </p:spPr>
+        <p:txBody>
+          <a:bodyPr wrap="square" lIns="0" tIns="0" rIns="0" bIns="0" rtlCol="0" anchor="ctr"/>
+          <a:lstStyle/>
+          <a:p>
+            <a:pPr marL="0" indent="0" algn="ctr">
+              <a:buNone/>
+            </a:pPr>
+            <a:r>
+              <a:rPr lang="en-US" sz="1300" b="1" dirty="0">
+                <a:solidFill>
+                  <a:srgbClr val="FFFFFF"/>
+                </a:solidFill>
+                <a:latin typeface="Calibri" pitchFamily="34" charset="0"/>
+                <a:ea typeface="Calibri" pitchFamily="34" charset="-122"/>
+                <a:cs typeface="Calibri" pitchFamily="34" charset="-120"/>
+              </a:rPr>
+              <a:t>Google ADK</a:t>
+            </a:r>
+            <a:endParaRPr lang="en-US" sz="1300" dirty="0"/>
+          </a:p>
+        </p:txBody>
+      </p:sp>
+      <p:sp>
+        <p:nvSpPr>
+          <p:cNvPr id="9" name="Text 6"/>
+          <p:cNvSpPr/>
+          <p:nvPr/>
+        </p:nvSpPr>
+        <p:spPr>
+          <a:xfrm>
+            <a:off x="548640" y="2148840"/>
+            <a:ext cx="1828800" cy="731520"/>
           </a:xfrm>
           <a:prstGeom prst="rect">
             <a:avLst/>
@@ -2541,30 +2604,41 @@
               <a:buNone/>
             </a:pPr>
             <a:r>
-              <a:rPr lang="en-US" sz="1600" b="1" dirty="0">
-                <a:solidFill>
-                  <a:srgbClr val="00C2C7"/>
-                </a:solidFill>
-                <a:latin typeface="Calibri" pitchFamily="34" charset="0"/>
-                <a:ea typeface="Calibri" pitchFamily="34" charset="-122"/>
-                <a:cs typeface="Calibri" pitchFamily="34" charset="-120"/>
-              </a:rPr>
-              <a:t>01</a:t>
-            </a:r>
-            <a:endParaRPr lang="en-US" sz="1600" dirty="0"/>
-          </a:p>
-        </p:txBody>
-      </p:sp>
-      <p:sp>
-        <p:nvSpPr>
-          <p:cNvPr id="8" name="Text 6"/>
-          <p:cNvSpPr/>
-          <p:nvPr/>
-        </p:nvSpPr>
-        <p:spPr>
-          <a:xfrm>
-            <a:off x="621792" y="1280160"/>
-            <a:ext cx="3749040" cy="274320"/>
+              <a:rPr lang="en-US" sz="1000" dirty="0">
+                <a:solidFill>
+                  <a:srgbClr val="028090"/>
+                </a:solidFill>
+                <a:latin typeface="Calibri" pitchFamily="34" charset="0"/>
+                <a:ea typeface="Calibri" pitchFamily="34" charset="-122"/>
+                <a:cs typeface="Calibri" pitchFamily="34" charset="-120"/>
+              </a:rPr>
+              <a:t>· </a:t>
+            </a:r>
+            <a:r>
+              <a:rPr lang="en-US" sz="1000" dirty="0">
+                <a:solidFill>
+                  <a:srgbClr val="E8F4F8"/>
+                </a:solidFill>
+                <a:latin typeface="Calibri" pitchFamily="34" charset="0"/>
+                <a:ea typeface="Calibri" pitchFamily="34" charset="-122"/>
+                <a:cs typeface="Calibri" pitchFamily="34" charset="-120"/>
+              </a:rPr>
+              <a:t>Native hierarchical agent orchestration</a:t>
+            </a:r>
+            <a:endParaRPr lang="en-US" sz="1000" dirty="0"/>
+          </a:p>
+        </p:txBody>
+      </p:sp>
+      <p:sp>
+        <p:nvSpPr>
+          <p:cNvPr id="10" name="Text 7"/>
+          <p:cNvSpPr/>
+          <p:nvPr/>
+        </p:nvSpPr>
+        <p:spPr>
+          <a:xfrm>
+            <a:off x="548640" y="2971800"/>
+            <a:ext cx="1828800" cy="731520"/>
           </a:xfrm>
           <a:prstGeom prst="rect">
             <a:avLst/>
@@ -2580,30 +2654,41 @@
               <a:buNone/>
             </a:pPr>
             <a:r>
-              <a:rPr lang="en-US" sz="1200" b="1" dirty="0">
-                <a:solidFill>
-                  <a:srgbClr val="1E293B"/>
-                </a:solidFill>
-                <a:latin typeface="Calibri" pitchFamily="34" charset="0"/>
-                <a:ea typeface="Calibri" pitchFamily="34" charset="-122"/>
-                <a:cs typeface="Calibri" pitchFamily="34" charset="-120"/>
-              </a:rPr>
-              <a:t>Architecture &amp; Design First</a:t>
-            </a:r>
-            <a:endParaRPr lang="en-US" sz="1200" dirty="0"/>
-          </a:p>
-        </p:txBody>
-      </p:sp>
-      <p:sp>
-        <p:nvSpPr>
-          <p:cNvPr id="9" name="Text 7"/>
-          <p:cNvSpPr/>
-          <p:nvPr/>
-        </p:nvSpPr>
-        <p:spPr>
-          <a:xfrm>
-            <a:off x="621792" y="1581912"/>
-            <a:ext cx="3749040" cy="457200"/>
+              <a:rPr lang="en-US" sz="1000" dirty="0">
+                <a:solidFill>
+                  <a:srgbClr val="028090"/>
+                </a:solidFill>
+                <a:latin typeface="Calibri" pitchFamily="34" charset="0"/>
+                <a:ea typeface="Calibri" pitchFamily="34" charset="-122"/>
+                <a:cs typeface="Calibri" pitchFamily="34" charset="-120"/>
+              </a:rPr>
+              <a:t>· </a:t>
+            </a:r>
+            <a:r>
+              <a:rPr lang="en-US" sz="1000" dirty="0">
+                <a:solidFill>
+                  <a:srgbClr val="E8F4F8"/>
+                </a:solidFill>
+                <a:latin typeface="Calibri" pitchFamily="34" charset="0"/>
+                <a:ea typeface="Calibri" pitchFamily="34" charset="-122"/>
+                <a:cs typeface="Calibri" pitchFamily="34" charset="-120"/>
+              </a:rPr>
+              <a:t>transfer_to_agent() as the primary delegation primitive</a:t>
+            </a:r>
+            <a:endParaRPr lang="en-US" sz="1000" dirty="0"/>
+          </a:p>
+        </p:txBody>
+      </p:sp>
+      <p:sp>
+        <p:nvSpPr>
+          <p:cNvPr id="11" name="Text 8"/>
+          <p:cNvSpPr/>
+          <p:nvPr/>
+        </p:nvSpPr>
+        <p:spPr>
+          <a:xfrm>
+            <a:off x="548640" y="3794760"/>
+            <a:ext cx="1828800" cy="731520"/>
           </a:xfrm>
           <a:prstGeom prst="rect">
             <a:avLst/>
@@ -2621,13 +2706,24 @@
             <a:r>
               <a:rPr lang="en-US" sz="1000" dirty="0">
                 <a:solidFill>
-                  <a:srgbClr val="475569"/>
-                </a:solidFill>
-                <a:latin typeface="Calibri" pitchFamily="34" charset="0"/>
-                <a:ea typeface="Calibri" pitchFamily="34" charset="-122"/>
-                <a:cs typeface="Calibri" pitchFamily="34" charset="-120"/>
-              </a:rPr>
-              <a:t>Started with AGENTS.md, CLAUDE.md, and a full C4-style architecture brief. System prompt design was the first artifact — not code.</a:t>
+                  <a:srgbClr val="028090"/>
+                </a:solidFill>
+                <a:latin typeface="Calibri" pitchFamily="34" charset="0"/>
+                <a:ea typeface="Calibri" pitchFamily="34" charset="-122"/>
+                <a:cs typeface="Calibri" pitchFamily="34" charset="-120"/>
+              </a:rPr>
+              <a:t>· </a:t>
+            </a:r>
+            <a:r>
+              <a:rPr lang="en-US" sz="1000" dirty="0">
+                <a:solidFill>
+                  <a:srgbClr val="E8F4F8"/>
+                </a:solidFill>
+                <a:latin typeface="Calibri" pitchFamily="34" charset="0"/>
+                <a:ea typeface="Calibri" pitchFamily="34" charset="-122"/>
+                <a:cs typeface="Calibri" pitchFamily="34" charset="-120"/>
+              </a:rPr>
+              <a:t>Session state shared across all agents without custom sync</a:t>
             </a:r>
             <a:endParaRPr lang="en-US" sz="1000" dirty="0"/>
           </a:p>
@@ -2635,26 +2731,26 @@
       </p:sp>
       <p:sp>
         <p:nvSpPr>
-          <p:cNvPr id="10" name="Shape 8"/>
-          <p:cNvSpPr/>
-          <p:nvPr/>
-        </p:nvSpPr>
-        <p:spPr>
-          <a:xfrm>
-            <a:off x="457200" y="2240280"/>
-            <a:ext cx="4114800" cy="1188720"/>
-          </a:xfrm>
-          <a:prstGeom prst="rect">
-            <a:avLst/>
-          </a:prstGeom>
-          <a:solidFill>
-            <a:srgbClr val="FFFFFF"/>
+          <p:cNvPr id="12" name="Shape 9"/>
+          <p:cNvSpPr/>
+          <p:nvPr/>
+        </p:nvSpPr>
+        <p:spPr>
+          <a:xfrm>
+            <a:off x="2651760" y="914400"/>
+            <a:ext cx="2011680" cy="3931920"/>
+          </a:xfrm>
+          <a:prstGeom prst="rect">
+            <a:avLst/>
+          </a:prstGeom>
+          <a:solidFill>
+            <a:srgbClr val="102B5A"/>
           </a:solidFill>
           <a:ln/>
           <a:effectLst>
             <a:outerShdw blurRad="101600" dist="25400" dir="8100000" algn="bl" rotWithShape="0">
               <a:srgbClr val="000000">
-                <a:alpha val="10000"/>
+                <a:alpha val="30000"/>
               </a:srgbClr>
             </a:outerShdw>
           </a:effectLst>
@@ -2669,41 +2765,104 @@
       </p:sp>
       <p:sp>
         <p:nvSpPr>
-          <p:cNvPr id="11" name="Shape 9"/>
-          <p:cNvSpPr/>
-          <p:nvPr/>
-        </p:nvSpPr>
-        <p:spPr>
-          <a:xfrm>
-            <a:off x="457200" y="2240280"/>
-            <a:ext cx="54864" cy="1188720"/>
-          </a:xfrm>
-          <a:prstGeom prst="rect">
-            <a:avLst/>
-          </a:prstGeom>
-          <a:solidFill>
-            <a:srgbClr val="00C2C7"/>
-          </a:solidFill>
-          <a:ln/>
-        </p:spPr>
-        <p:txBody>
-          <a:bodyPr/>
-          <a:lstStyle/>
-          <a:p>
-            <a:endParaRPr lang="en-US"/>
-          </a:p>
-        </p:txBody>
-      </p:sp>
-      <p:sp>
-        <p:nvSpPr>
-          <p:cNvPr id="12" name="Text 10"/>
-          <p:cNvSpPr/>
-          <p:nvPr/>
-        </p:nvSpPr>
-        <p:spPr>
-          <a:xfrm>
-            <a:off x="621792" y="2313432"/>
-            <a:ext cx="457200" cy="274320"/>
+          <p:cNvPr id="13" name="Shape 10"/>
+          <p:cNvSpPr/>
+          <p:nvPr/>
+        </p:nvSpPr>
+        <p:spPr>
+          <a:xfrm>
+            <a:off x="2651760" y="914400"/>
+            <a:ext cx="2011680" cy="64008"/>
+          </a:xfrm>
+          <a:prstGeom prst="rect">
+            <a:avLst/>
+          </a:prstGeom>
+          <a:solidFill>
+            <a:srgbClr val="22D3A5"/>
+          </a:solidFill>
+          <a:ln/>
+        </p:spPr>
+        <p:txBody>
+          <a:bodyPr/>
+          <a:lstStyle/>
+          <a:p>
+            <a:endParaRPr lang="en-US"/>
+          </a:p>
+        </p:txBody>
+      </p:sp>
+      <p:pic>
+        <p:nvPicPr>
+          <p:cNvPr id="14" name="Image 1" descr="preencoded.png"/>
+          <p:cNvPicPr>
+            <a:picLocks noChangeAspect="1"/>
+          </p:cNvPicPr>
+          <p:nvPr/>
+        </p:nvPicPr>
+        <p:blipFill>
+          <a:blip r:embed="rId4"/>
+          <a:stretch>
+            <a:fillRect/>
+          </a:stretch>
+        </p:blipFill>
+        <p:spPr>
+          <a:xfrm>
+            <a:off x="3383280" y="1097280"/>
+            <a:ext cx="502920" cy="502920"/>
+          </a:xfrm>
+          <a:prstGeom prst="rect">
+            <a:avLst/>
+          </a:prstGeom>
+        </p:spPr>
+      </p:pic>
+      <p:sp>
+        <p:nvSpPr>
+          <p:cNvPr id="15" name="Text 11"/>
+          <p:cNvSpPr/>
+          <p:nvPr/>
+        </p:nvSpPr>
+        <p:spPr>
+          <a:xfrm>
+            <a:off x="2743200" y="1691640"/>
+            <a:ext cx="1828800" cy="365760"/>
+          </a:xfrm>
+          <a:prstGeom prst="rect">
+            <a:avLst/>
+          </a:prstGeom>
+          <a:noFill/>
+          <a:ln/>
+        </p:spPr>
+        <p:txBody>
+          <a:bodyPr wrap="square" lIns="0" tIns="0" rIns="0" bIns="0" rtlCol="0" anchor="ctr"/>
+          <a:lstStyle/>
+          <a:p>
+            <a:pPr marL="0" indent="0" algn="ctr">
+              <a:buNone/>
+            </a:pPr>
+            <a:r>
+              <a:rPr lang="en-US" sz="1300" b="1" dirty="0">
+                <a:solidFill>
+                  <a:srgbClr val="FFFFFF"/>
+                </a:solidFill>
+                <a:latin typeface="Calibri" pitchFamily="34" charset="0"/>
+                <a:ea typeface="Calibri" pitchFamily="34" charset="-122"/>
+                <a:cs typeface="Calibri" pitchFamily="34" charset="-120"/>
+              </a:rPr>
+              <a:t>Cable/MSO Domain</a:t>
+            </a:r>
+            <a:endParaRPr lang="en-US" sz="1300" dirty="0"/>
+          </a:p>
+        </p:txBody>
+      </p:sp>
+      <p:sp>
+        <p:nvSpPr>
+          <p:cNvPr id="16" name="Text 12"/>
+          <p:cNvSpPr/>
+          <p:nvPr/>
+        </p:nvSpPr>
+        <p:spPr>
+          <a:xfrm>
+            <a:off x="2743200" y="2148840"/>
+            <a:ext cx="1828800" cy="731520"/>
           </a:xfrm>
           <a:prstGeom prst="rect">
             <a:avLst/>
@@ -2719,30 +2878,41 @@
               <a:buNone/>
             </a:pPr>
             <a:r>
-              <a:rPr lang="en-US" sz="1600" b="1" dirty="0">
-                <a:solidFill>
-                  <a:srgbClr val="00C2C7"/>
-                </a:solidFill>
-                <a:latin typeface="Calibri" pitchFamily="34" charset="0"/>
-                <a:ea typeface="Calibri" pitchFamily="34" charset="-122"/>
-                <a:cs typeface="Calibri" pitchFamily="34" charset="-120"/>
-              </a:rPr>
-              <a:t>02</a:t>
-            </a:r>
-            <a:endParaRPr lang="en-US" sz="1600" dirty="0"/>
-          </a:p>
-        </p:txBody>
-      </p:sp>
-      <p:sp>
-        <p:nvSpPr>
-          <p:cNvPr id="13" name="Text 11"/>
-          <p:cNvSpPr/>
-          <p:nvPr/>
-        </p:nvSpPr>
-        <p:spPr>
-          <a:xfrm>
-            <a:off x="621792" y="2606040"/>
-            <a:ext cx="3749040" cy="274320"/>
+              <a:rPr lang="en-US" sz="1000" dirty="0">
+                <a:solidFill>
+                  <a:srgbClr val="22D3A5"/>
+                </a:solidFill>
+                <a:latin typeface="Calibri" pitchFamily="34" charset="0"/>
+                <a:ea typeface="Calibri" pitchFamily="34" charset="-122"/>
+                <a:cs typeface="Calibri" pitchFamily="34" charset="-120"/>
+              </a:rPr>
+              <a:t>· </a:t>
+            </a:r>
+            <a:r>
+              <a:rPr lang="en-US" sz="1000" dirty="0">
+                <a:solidFill>
+                  <a:srgbClr val="E8F4F8"/>
+                </a:solidFill>
+                <a:latin typeface="Calibri" pitchFamily="34" charset="0"/>
+                <a:ea typeface="Calibri" pitchFamily="34" charset="-122"/>
+                <a:cs typeface="Calibri" pitchFamily="34" charset="-120"/>
+              </a:rPr>
+              <a:t>Real Comcast B2B product taxonomy mapped to agents</a:t>
+            </a:r>
+            <a:endParaRPr lang="en-US" sz="1000" dirty="0"/>
+          </a:p>
+        </p:txBody>
+      </p:sp>
+      <p:sp>
+        <p:nvSpPr>
+          <p:cNvPr id="17" name="Text 13"/>
+          <p:cNvSpPr/>
+          <p:nvPr/>
+        </p:nvSpPr>
+        <p:spPr>
+          <a:xfrm>
+            <a:off x="2743200" y="2971800"/>
+            <a:ext cx="1828800" cy="731520"/>
           </a:xfrm>
           <a:prstGeom prst="rect">
             <a:avLst/>
@@ -2758,30 +2928,41 @@
               <a:buNone/>
             </a:pPr>
             <a:r>
-              <a:rPr lang="en-US" sz="1200" b="1" dirty="0">
-                <a:solidFill>
-                  <a:srgbClr val="1E293B"/>
-                </a:solidFill>
-                <a:latin typeface="Calibri" pitchFamily="34" charset="0"/>
-                <a:ea typeface="Calibri" pitchFamily="34" charset="-122"/>
-                <a:cs typeface="Calibri" pitchFamily="34" charset="-120"/>
-              </a:rPr>
-              <a:t>AI-Assisted Development</a:t>
-            </a:r>
-            <a:endParaRPr lang="en-US" sz="1200" dirty="0"/>
-          </a:p>
-        </p:txBody>
-      </p:sp>
-      <p:sp>
-        <p:nvSpPr>
-          <p:cNvPr id="14" name="Text 12"/>
-          <p:cNvSpPr/>
-          <p:nvPr/>
-        </p:nvSpPr>
-        <p:spPr>
-          <a:xfrm>
-            <a:off x="621792" y="2907792"/>
-            <a:ext cx="3749040" cy="457200"/>
+              <a:rPr lang="en-US" sz="1000" dirty="0">
+                <a:solidFill>
+                  <a:srgbClr val="22D3A5"/>
+                </a:solidFill>
+                <a:latin typeface="Calibri" pitchFamily="34" charset="0"/>
+                <a:ea typeface="Calibri" pitchFamily="34" charset="-122"/>
+                <a:cs typeface="Calibri" pitchFamily="34" charset="-120"/>
+              </a:rPr>
+              <a:t>· </a:t>
+            </a:r>
+            <a:r>
+              <a:rPr lang="en-US" sz="1000" dirty="0">
+                <a:solidFill>
+                  <a:srgbClr val="E8F4F8"/>
+                </a:solidFill>
+                <a:latin typeface="Calibri" pitchFamily="34" charset="0"/>
+                <a:ea typeface="Calibri" pitchFamily="34" charset="-122"/>
+                <a:cs typeface="Calibri" pitchFamily="34" charset="-120"/>
+              </a:rPr>
+              <a:t>Serviceability check mirrors actual BSS/OSS pre-sales flow</a:t>
+            </a:r>
+            <a:endParaRPr lang="en-US" sz="1000" dirty="0"/>
+          </a:p>
+        </p:txBody>
+      </p:sp>
+      <p:sp>
+        <p:nvSpPr>
+          <p:cNvPr id="18" name="Text 14"/>
+          <p:cNvSpPr/>
+          <p:nvPr/>
+        </p:nvSpPr>
+        <p:spPr>
+          <a:xfrm>
+            <a:off x="2743200" y="3794760"/>
+            <a:ext cx="1828800" cy="731520"/>
           </a:xfrm>
           <a:prstGeom prst="rect">
             <a:avLst/>
@@ -2799,13 +2980,24 @@
             <a:r>
               <a:rPr lang="en-US" sz="1000" dirty="0">
                 <a:solidFill>
-                  <a:srgbClr val="475569"/>
-                </a:solidFill>
-                <a:latin typeface="Calibri" pitchFamily="34" charset="0"/>
-                <a:ea typeface="Calibri" pitchFamily="34" charset="-122"/>
-                <a:cs typeface="Calibri" pitchFamily="34" charset="-120"/>
-              </a:rPr>
-              <a:t>Claude Code used for scaffolding agents, FastAPI routes, and React components. ~70% of boilerplate generated; 100% human-reviewed for ADK correctness.</a:t>
+                  <a:srgbClr val="22D3A5"/>
+                </a:solidFill>
+                <a:latin typeface="Calibri" pitchFamily="34" charset="0"/>
+                <a:ea typeface="Calibri" pitchFamily="34" charset="-122"/>
+                <a:cs typeface="Calibri" pitchFamily="34" charset="-120"/>
+              </a:rPr>
+              <a:t>· </a:t>
+            </a:r>
+            <a:r>
+              <a:rPr lang="en-US" sz="1000" dirty="0">
+                <a:solidFill>
+                  <a:srgbClr val="E8F4F8"/>
+                </a:solidFill>
+                <a:latin typeface="Calibri" pitchFamily="34" charset="0"/>
+                <a:ea typeface="Calibri" pitchFamily="34" charset="-122"/>
+                <a:cs typeface="Calibri" pitchFamily="34" charset="-120"/>
+              </a:rPr>
+              <a:t>Pricing/discount logic mirrors real enterprise telco quoting</a:t>
             </a:r>
             <a:endParaRPr lang="en-US" sz="1000" dirty="0"/>
           </a:p>
@@ -2813,26 +3005,26 @@
       </p:sp>
       <p:sp>
         <p:nvSpPr>
-          <p:cNvPr id="15" name="Shape 13"/>
-          <p:cNvSpPr/>
-          <p:nvPr/>
-        </p:nvSpPr>
-        <p:spPr>
-          <a:xfrm>
-            <a:off x="457200" y="3566160"/>
-            <a:ext cx="4114800" cy="1188720"/>
-          </a:xfrm>
-          <a:prstGeom prst="rect">
-            <a:avLst/>
-          </a:prstGeom>
-          <a:solidFill>
-            <a:srgbClr val="FFFFFF"/>
+          <p:cNvPr id="19" name="Shape 15"/>
+          <p:cNvSpPr/>
+          <p:nvPr/>
+        </p:nvSpPr>
+        <p:spPr>
+          <a:xfrm>
+            <a:off x="4846320" y="914400"/>
+            <a:ext cx="2011680" cy="3931920"/>
+          </a:xfrm>
+          <a:prstGeom prst="rect">
+            <a:avLst/>
+          </a:prstGeom>
+          <a:solidFill>
+            <a:srgbClr val="102B5A"/>
           </a:solidFill>
           <a:ln/>
           <a:effectLst>
             <a:outerShdw blurRad="101600" dist="25400" dir="8100000" algn="bl" rotWithShape="0">
               <a:srgbClr val="000000">
-                <a:alpha val="10000"/>
+                <a:alpha val="30000"/>
               </a:srgbClr>
             </a:outerShdw>
           </a:effectLst>
@@ -2847,41 +3039,104 @@
       </p:sp>
       <p:sp>
         <p:nvSpPr>
-          <p:cNvPr id="16" name="Shape 14"/>
-          <p:cNvSpPr/>
-          <p:nvPr/>
-        </p:nvSpPr>
-        <p:spPr>
-          <a:xfrm>
-            <a:off x="457200" y="3566160"/>
-            <a:ext cx="54864" cy="1188720"/>
-          </a:xfrm>
-          <a:prstGeom prst="rect">
-            <a:avLst/>
-          </a:prstGeom>
-          <a:solidFill>
-            <a:srgbClr val="00C2C7"/>
-          </a:solidFill>
-          <a:ln/>
-        </p:spPr>
-        <p:txBody>
-          <a:bodyPr/>
-          <a:lstStyle/>
-          <a:p>
-            <a:endParaRPr lang="en-US"/>
-          </a:p>
-        </p:txBody>
-      </p:sp>
-      <p:sp>
-        <p:nvSpPr>
-          <p:cNvPr id="17" name="Text 15"/>
-          <p:cNvSpPr/>
-          <p:nvPr/>
-        </p:nvSpPr>
-        <p:spPr>
-          <a:xfrm>
-            <a:off x="621792" y="3639312"/>
-            <a:ext cx="457200" cy="274320"/>
+          <p:cNvPr id="20" name="Shape 16"/>
+          <p:cNvSpPr/>
+          <p:nvPr/>
+        </p:nvSpPr>
+        <p:spPr>
+          <a:xfrm>
+            <a:off x="4846320" y="914400"/>
+            <a:ext cx="2011680" cy="64008"/>
+          </a:xfrm>
+          <a:prstGeom prst="rect">
+            <a:avLst/>
+          </a:prstGeom>
+          <a:solidFill>
+            <a:srgbClr val="F59E0B"/>
+          </a:solidFill>
+          <a:ln/>
+        </p:spPr>
+        <p:txBody>
+          <a:bodyPr/>
+          <a:lstStyle/>
+          <a:p>
+            <a:endParaRPr lang="en-US"/>
+          </a:p>
+        </p:txBody>
+      </p:sp>
+      <p:pic>
+        <p:nvPicPr>
+          <p:cNvPr id="21" name="Image 2" descr="preencoded.png"/>
+          <p:cNvPicPr>
+            <a:picLocks noChangeAspect="1"/>
+          </p:cNvPicPr>
+          <p:nvPr/>
+        </p:nvPicPr>
+        <p:blipFill>
+          <a:blip r:embed="rId5"/>
+          <a:stretch>
+            <a:fillRect/>
+          </a:stretch>
+        </p:blipFill>
+        <p:spPr>
+          <a:xfrm>
+            <a:off x="5577840" y="1097280"/>
+            <a:ext cx="502920" cy="502920"/>
+          </a:xfrm>
+          <a:prstGeom prst="rect">
+            <a:avLst/>
+          </a:prstGeom>
+        </p:spPr>
+      </p:pic>
+      <p:sp>
+        <p:nvSpPr>
+          <p:cNvPr id="22" name="Text 17"/>
+          <p:cNvSpPr/>
+          <p:nvPr/>
+        </p:nvSpPr>
+        <p:spPr>
+          <a:xfrm>
+            <a:off x="4937760" y="1691640"/>
+            <a:ext cx="1828800" cy="365760"/>
+          </a:xfrm>
+          <a:prstGeom prst="rect">
+            <a:avLst/>
+          </a:prstGeom>
+          <a:noFill/>
+          <a:ln/>
+        </p:spPr>
+        <p:txBody>
+          <a:bodyPr wrap="square" lIns="0" tIns="0" rIns="0" bIns="0" rtlCol="0" anchor="ctr"/>
+          <a:lstStyle/>
+          <a:p>
+            <a:pPr marL="0" indent="0" algn="ctr">
+              <a:buNone/>
+            </a:pPr>
+            <a:r>
+              <a:rPr lang="en-US" sz="1300" b="1" dirty="0">
+                <a:solidFill>
+                  <a:srgbClr val="FFFFFF"/>
+                </a:solidFill>
+                <a:latin typeface="Calibri" pitchFamily="34" charset="0"/>
+                <a:ea typeface="Calibri" pitchFamily="34" charset="-122"/>
+                <a:cs typeface="Calibri" pitchFamily="34" charset="-120"/>
+              </a:rPr>
+              <a:t>Academic Grounding</a:t>
+            </a:r>
+            <a:endParaRPr lang="en-US" sz="1300" dirty="0"/>
+          </a:p>
+        </p:txBody>
+      </p:sp>
+      <p:sp>
+        <p:nvSpPr>
+          <p:cNvPr id="23" name="Text 18"/>
+          <p:cNvSpPr/>
+          <p:nvPr/>
+        </p:nvSpPr>
+        <p:spPr>
+          <a:xfrm>
+            <a:off x="4937760" y="2148840"/>
+            <a:ext cx="1828800" cy="731520"/>
           </a:xfrm>
           <a:prstGeom prst="rect">
             <a:avLst/>
@@ -2897,30 +3152,41 @@
               <a:buNone/>
             </a:pPr>
             <a:r>
-              <a:rPr lang="en-US" sz="1600" b="1" dirty="0">
-                <a:solidFill>
-                  <a:srgbClr val="00C2C7"/>
-                </a:solidFill>
-                <a:latin typeface="Calibri" pitchFamily="34" charset="0"/>
-                <a:ea typeface="Calibri" pitchFamily="34" charset="-122"/>
-                <a:cs typeface="Calibri" pitchFamily="34" charset="-120"/>
-              </a:rPr>
-              <a:t>03</a:t>
-            </a:r>
-            <a:endParaRPr lang="en-US" sz="1600" dirty="0"/>
-          </a:p>
-        </p:txBody>
-      </p:sp>
-      <p:sp>
-        <p:nvSpPr>
-          <p:cNvPr id="18" name="Text 16"/>
-          <p:cNvSpPr/>
-          <p:nvPr/>
-        </p:nvSpPr>
-        <p:spPr>
-          <a:xfrm>
-            <a:off x="621792" y="3931920"/>
-            <a:ext cx="3749040" cy="274320"/>
+              <a:rPr lang="en-US" sz="1000" dirty="0">
+                <a:solidFill>
+                  <a:srgbClr val="F59E0B"/>
+                </a:solidFill>
+                <a:latin typeface="Calibri" pitchFamily="34" charset="0"/>
+                <a:ea typeface="Calibri" pitchFamily="34" charset="-122"/>
+                <a:cs typeface="Calibri" pitchFamily="34" charset="-120"/>
+              </a:rPr>
+              <a:t>· </a:t>
+            </a:r>
+            <a:r>
+              <a:rPr lang="en-US" sz="1000" dirty="0">
+                <a:solidFill>
+                  <a:srgbClr val="E8F4F8"/>
+                </a:solidFill>
+                <a:latin typeface="Calibri" pitchFamily="34" charset="0"/>
+                <a:ea typeface="Calibri" pitchFamily="34" charset="-122"/>
+                <a:cs typeface="Calibri" pitchFamily="34" charset="-120"/>
+              </a:rPr>
+              <a:t>Multi-agent LLM orchestration literature</a:t>
+            </a:r>
+            <a:endParaRPr lang="en-US" sz="1000" dirty="0"/>
+          </a:p>
+        </p:txBody>
+      </p:sp>
+      <p:sp>
+        <p:nvSpPr>
+          <p:cNvPr id="24" name="Text 19"/>
+          <p:cNvSpPr/>
+          <p:nvPr/>
+        </p:nvSpPr>
+        <p:spPr>
+          <a:xfrm>
+            <a:off x="4937760" y="2971800"/>
+            <a:ext cx="1828800" cy="731520"/>
           </a:xfrm>
           <a:prstGeom prst="rect">
             <a:avLst/>
@@ -2936,30 +3202,41 @@
               <a:buNone/>
             </a:pPr>
             <a:r>
-              <a:rPr lang="en-US" sz="1200" b="1" dirty="0">
-                <a:solidFill>
-                  <a:srgbClr val="1E293B"/>
-                </a:solidFill>
-                <a:latin typeface="Calibri" pitchFamily="34" charset="0"/>
-                <a:ea typeface="Calibri" pitchFamily="34" charset="-122"/>
-                <a:cs typeface="Calibri" pitchFamily="34" charset="-120"/>
-              </a:rPr>
-              <a:t>Human Judgment on Critical Paths</a:t>
-            </a:r>
-            <a:endParaRPr lang="en-US" sz="1200" dirty="0"/>
-          </a:p>
-        </p:txBody>
-      </p:sp>
-      <p:sp>
-        <p:nvSpPr>
-          <p:cNvPr id="19" name="Text 17"/>
-          <p:cNvSpPr/>
-          <p:nvPr/>
-        </p:nvSpPr>
-        <p:spPr>
-          <a:xfrm>
-            <a:off x="621792" y="4233672"/>
-            <a:ext cx="3749040" cy="457200"/>
+              <a:rPr lang="en-US" sz="1000" dirty="0">
+                <a:solidFill>
+                  <a:srgbClr val="F59E0B"/>
+                </a:solidFill>
+                <a:latin typeface="Calibri" pitchFamily="34" charset="0"/>
+                <a:ea typeface="Calibri" pitchFamily="34" charset="-122"/>
+                <a:cs typeface="Calibri" pitchFamily="34" charset="-120"/>
+              </a:rPr>
+              <a:t>· </a:t>
+            </a:r>
+            <a:r>
+              <a:rPr lang="en-US" sz="1000" dirty="0">
+                <a:solidFill>
+                  <a:srgbClr val="E8F4F8"/>
+                </a:solidFill>
+                <a:latin typeface="Calibri" pitchFamily="34" charset="0"/>
+                <a:ea typeface="Calibri" pitchFamily="34" charset="-122"/>
+                <a:cs typeface="Calibri" pitchFamily="34" charset="-120"/>
+              </a:rPr>
+              <a:t>Hierarchical decomposition patterns for domain-specific agents</a:t>
+            </a:r>
+            <a:endParaRPr lang="en-US" sz="1000" dirty="0"/>
+          </a:p>
+        </p:txBody>
+      </p:sp>
+      <p:sp>
+        <p:nvSpPr>
+          <p:cNvPr id="25" name="Text 20"/>
+          <p:cNvSpPr/>
+          <p:nvPr/>
+        </p:nvSpPr>
+        <p:spPr>
+          <a:xfrm>
+            <a:off x="4937760" y="3794760"/>
+            <a:ext cx="1828800" cy="731520"/>
           </a:xfrm>
           <a:prstGeom prst="rect">
             <a:avLst/>
@@ -2977,13 +3254,24 @@
             <a:r>
               <a:rPr lang="en-US" sz="1000" dirty="0">
                 <a:solidFill>
-                  <a:srgbClr val="475569"/>
-                </a:solidFill>
-                <a:latin typeface="Calibri" pitchFamily="34" charset="0"/>
-                <a:ea typeface="Calibri" pitchFamily="34" charset="-122"/>
-                <a:cs typeface="Calibri" pitchFamily="34" charset="-120"/>
-              </a:rPr>
-              <a:t>Agent routing logic, temperature config, tool contract schemas, and importlib isolation — all human-authored. AI doesn't know our ADK constraints.</a:t>
+                  <a:srgbClr val="F59E0B"/>
+                </a:solidFill>
+                <a:latin typeface="Calibri" pitchFamily="34" charset="0"/>
+                <a:ea typeface="Calibri" pitchFamily="34" charset="-122"/>
+                <a:cs typeface="Calibri" pitchFamily="34" charset="-120"/>
+              </a:rPr>
+              <a:t>· </a:t>
+            </a:r>
+            <a:r>
+              <a:rPr lang="en-US" sz="1000" dirty="0">
+                <a:solidFill>
+                  <a:srgbClr val="E8F4F8"/>
+                </a:solidFill>
+                <a:latin typeface="Calibri" pitchFamily="34" charset="0"/>
+                <a:ea typeface="Calibri" pitchFamily="34" charset="-122"/>
+                <a:cs typeface="Calibri" pitchFamily="34" charset="-120"/>
+              </a:rPr>
+              <a:t>Tool-augmented LLM reasoning</a:t>
             </a:r>
             <a:endParaRPr lang="en-US" sz="1000" dirty="0"/>
           </a:p>
@@ -2991,26 +3279,26 @@
       </p:sp>
       <p:sp>
         <p:nvSpPr>
-          <p:cNvPr id="20" name="Shape 18"/>
-          <p:cNvSpPr/>
-          <p:nvPr/>
-        </p:nvSpPr>
-        <p:spPr>
-          <a:xfrm>
-            <a:off x="4846320" y="914400"/>
-            <a:ext cx="4114800" cy="1188720"/>
-          </a:xfrm>
-          <a:prstGeom prst="rect">
-            <a:avLst/>
-          </a:prstGeom>
-          <a:solidFill>
-            <a:srgbClr val="FFFFFF"/>
+          <p:cNvPr id="26" name="Shape 21"/>
+          <p:cNvSpPr/>
+          <p:nvPr/>
+        </p:nvSpPr>
+        <p:spPr>
+          <a:xfrm>
+            <a:off x="7040880" y="914400"/>
+            <a:ext cx="2011680" cy="3931920"/>
+          </a:xfrm>
+          <a:prstGeom prst="rect">
+            <a:avLst/>
+          </a:prstGeom>
+          <a:solidFill>
+            <a:srgbClr val="102B5A"/>
           </a:solidFill>
           <a:ln/>
           <a:effectLst>
             <a:outerShdw blurRad="101600" dist="25400" dir="8100000" algn="bl" rotWithShape="0">
               <a:srgbClr val="000000">
-                <a:alpha val="10000"/>
+                <a:alpha val="30000"/>
               </a:srgbClr>
             </a:outerShdw>
           </a:effectLst>
@@ -3025,41 +3313,104 @@
       </p:sp>
       <p:sp>
         <p:nvSpPr>
-          <p:cNvPr id="21" name="Shape 19"/>
-          <p:cNvSpPr/>
-          <p:nvPr/>
-        </p:nvSpPr>
-        <p:spPr>
-          <a:xfrm>
-            <a:off x="4846320" y="914400"/>
-            <a:ext cx="54864" cy="1188720"/>
-          </a:xfrm>
-          <a:prstGeom prst="rect">
-            <a:avLst/>
-          </a:prstGeom>
-          <a:solidFill>
-            <a:srgbClr val="00C2C7"/>
-          </a:solidFill>
-          <a:ln/>
-        </p:spPr>
-        <p:txBody>
-          <a:bodyPr/>
-          <a:lstStyle/>
-          <a:p>
-            <a:endParaRPr lang="en-US"/>
-          </a:p>
-        </p:txBody>
-      </p:sp>
-      <p:sp>
-        <p:nvSpPr>
-          <p:cNvPr id="22" name="Text 20"/>
-          <p:cNvSpPr/>
-          <p:nvPr/>
-        </p:nvSpPr>
-        <p:spPr>
-          <a:xfrm>
-            <a:off x="5010912" y="987552"/>
-            <a:ext cx="457200" cy="274320"/>
+          <p:cNvPr id="27" name="Shape 22"/>
+          <p:cNvSpPr/>
+          <p:nvPr/>
+        </p:nvSpPr>
+        <p:spPr>
+          <a:xfrm>
+            <a:off x="7040880" y="914400"/>
+            <a:ext cx="2011680" cy="64008"/>
+          </a:xfrm>
+          <a:prstGeom prst="rect">
+            <a:avLst/>
+          </a:prstGeom>
+          <a:solidFill>
+            <a:srgbClr val="C084FC"/>
+          </a:solidFill>
+          <a:ln/>
+        </p:spPr>
+        <p:txBody>
+          <a:bodyPr/>
+          <a:lstStyle/>
+          <a:p>
+            <a:endParaRPr lang="en-US"/>
+          </a:p>
+        </p:txBody>
+      </p:sp>
+      <p:pic>
+        <p:nvPicPr>
+          <p:cNvPr id="28" name="Image 3" descr="preencoded.png"/>
+          <p:cNvPicPr>
+            <a:picLocks noChangeAspect="1"/>
+          </p:cNvPicPr>
+          <p:nvPr/>
+        </p:nvPicPr>
+        <p:blipFill>
+          <a:blip r:embed="rId6"/>
+          <a:stretch>
+            <a:fillRect/>
+          </a:stretch>
+        </p:blipFill>
+        <p:spPr>
+          <a:xfrm>
+            <a:off x="7772400" y="1097280"/>
+            <a:ext cx="502920" cy="502920"/>
+          </a:xfrm>
+          <a:prstGeom prst="rect">
+            <a:avLst/>
+          </a:prstGeom>
+        </p:spPr>
+      </p:pic>
+      <p:sp>
+        <p:nvSpPr>
+          <p:cNvPr id="29" name="Text 23"/>
+          <p:cNvSpPr/>
+          <p:nvPr/>
+        </p:nvSpPr>
+        <p:spPr>
+          <a:xfrm>
+            <a:off x="7132320" y="1691640"/>
+            <a:ext cx="1828800" cy="365760"/>
+          </a:xfrm>
+          <a:prstGeom prst="rect">
+            <a:avLst/>
+          </a:prstGeom>
+          <a:noFill/>
+          <a:ln/>
+        </p:spPr>
+        <p:txBody>
+          <a:bodyPr wrap="square" lIns="0" tIns="0" rIns="0" bIns="0" rtlCol="0" anchor="ctr"/>
+          <a:lstStyle/>
+          <a:p>
+            <a:pPr marL="0" indent="0" algn="ctr">
+              <a:buNone/>
+            </a:pPr>
+            <a:r>
+              <a:rPr lang="en-US" sz="1300" b="1" dirty="0">
+                <a:solidFill>
+                  <a:srgbClr val="FFFFFF"/>
+                </a:solidFill>
+                <a:latin typeface="Calibri" pitchFamily="34" charset="0"/>
+                <a:ea typeface="Calibri" pitchFamily="34" charset="-122"/>
+                <a:cs typeface="Calibri" pitchFamily="34" charset="-120"/>
+              </a:rPr>
+              <a:t>Gemini API / ADK Shell</a:t>
+            </a:r>
+            <a:endParaRPr lang="en-US" sz="1300" dirty="0"/>
+          </a:p>
+        </p:txBody>
+      </p:sp>
+      <p:sp>
+        <p:nvSpPr>
+          <p:cNvPr id="30" name="Text 24"/>
+          <p:cNvSpPr/>
+          <p:nvPr/>
+        </p:nvSpPr>
+        <p:spPr>
+          <a:xfrm>
+            <a:off x="7132320" y="2148840"/>
+            <a:ext cx="1828800" cy="731520"/>
           </a:xfrm>
           <a:prstGeom prst="rect">
             <a:avLst/>
@@ -3075,30 +3426,41 @@
               <a:buNone/>
             </a:pPr>
             <a:r>
-              <a:rPr lang="en-US" sz="1600" b="1" dirty="0">
-                <a:solidFill>
-                  <a:srgbClr val="00C2C7"/>
-                </a:solidFill>
-                <a:latin typeface="Calibri" pitchFamily="34" charset="0"/>
-                <a:ea typeface="Calibri" pitchFamily="34" charset="-122"/>
-                <a:cs typeface="Calibri" pitchFamily="34" charset="-120"/>
-              </a:rPr>
-              <a:t>04</a:t>
-            </a:r>
-            <a:endParaRPr lang="en-US" sz="1600" dirty="0"/>
-          </a:p>
-        </p:txBody>
-      </p:sp>
-      <p:sp>
-        <p:nvSpPr>
-          <p:cNvPr id="23" name="Text 21"/>
-          <p:cNvSpPr/>
-          <p:nvPr/>
-        </p:nvSpPr>
-        <p:spPr>
-          <a:xfrm>
-            <a:off x="5010912" y="1280160"/>
-            <a:ext cx="3749040" cy="274320"/>
+              <a:rPr lang="en-US" sz="1000" dirty="0">
+                <a:solidFill>
+                  <a:srgbClr val="C084FC"/>
+                </a:solidFill>
+                <a:latin typeface="Calibri" pitchFamily="34" charset="0"/>
+                <a:ea typeface="Calibri" pitchFamily="34" charset="-122"/>
+                <a:cs typeface="Calibri" pitchFamily="34" charset="-120"/>
+              </a:rPr>
+              <a:t>· </a:t>
+            </a:r>
+            <a:r>
+              <a:rPr lang="en-US" sz="1000" dirty="0">
+                <a:solidFill>
+                  <a:srgbClr val="E8F4F8"/>
+                </a:solidFill>
+                <a:latin typeface="Calibri" pitchFamily="34" charset="0"/>
+                <a:ea typeface="Calibri" pitchFamily="34" charset="-122"/>
+                <a:cs typeface="Calibri" pitchFamily="34" charset="-120"/>
+              </a:rPr>
+              <a:t>Gemini Flash for cost/speed tradeoff in production-grade use</a:t>
+            </a:r>
+            <a:endParaRPr lang="en-US" sz="1000" dirty="0"/>
+          </a:p>
+        </p:txBody>
+      </p:sp>
+      <p:sp>
+        <p:nvSpPr>
+          <p:cNvPr id="31" name="Text 25"/>
+          <p:cNvSpPr/>
+          <p:nvPr/>
+        </p:nvSpPr>
+        <p:spPr>
+          <a:xfrm>
+            <a:off x="7132320" y="2971800"/>
+            <a:ext cx="1828800" cy="731520"/>
           </a:xfrm>
           <a:prstGeom prst="rect">
             <a:avLst/>
@@ -3114,30 +3476,41 @@
               <a:buNone/>
             </a:pPr>
             <a:r>
-              <a:rPr lang="en-US" sz="1200" b="1" dirty="0">
-                <a:solidFill>
-                  <a:srgbClr val="1E293B"/>
-                </a:solidFill>
-                <a:latin typeface="Calibri" pitchFamily="34" charset="0"/>
-                <a:ea typeface="Calibri" pitchFamily="34" charset="-122"/>
-                <a:cs typeface="Calibri" pitchFamily="34" charset="-120"/>
-              </a:rPr>
-              <a:t>GitHub for Coordination</a:t>
-            </a:r>
-            <a:endParaRPr lang="en-US" sz="1200" dirty="0"/>
-          </a:p>
-        </p:txBody>
-      </p:sp>
-      <p:sp>
-        <p:nvSpPr>
-          <p:cNvPr id="24" name="Text 22"/>
-          <p:cNvSpPr/>
-          <p:nvPr/>
-        </p:nvSpPr>
-        <p:spPr>
-          <a:xfrm>
-            <a:off x="5010912" y="1581912"/>
-            <a:ext cx="3749040" cy="457200"/>
+              <a:rPr lang="en-US" sz="1000" dirty="0">
+                <a:solidFill>
+                  <a:srgbClr val="C084FC"/>
+                </a:solidFill>
+                <a:latin typeface="Calibri" pitchFamily="34" charset="0"/>
+                <a:ea typeface="Calibri" pitchFamily="34" charset="-122"/>
+                <a:cs typeface="Calibri" pitchFamily="34" charset="-120"/>
+              </a:rPr>
+              <a:t>· </a:t>
+            </a:r>
+            <a:r>
+              <a:rPr lang="en-US" sz="1000" dirty="0">
+                <a:solidFill>
+                  <a:srgbClr val="E8F4F8"/>
+                </a:solidFill>
+                <a:latin typeface="Calibri" pitchFamily="34" charset="0"/>
+                <a:ea typeface="Calibri" pitchFamily="34" charset="-122"/>
+                <a:cs typeface="Calibri" pitchFamily="34" charset="-120"/>
+              </a:rPr>
+              <a:t>ADK shell provides CLI + dev server for rapid agent iteration</a:t>
+            </a:r>
+            <a:endParaRPr lang="en-US" sz="1000" dirty="0"/>
+          </a:p>
+        </p:txBody>
+      </p:sp>
+      <p:sp>
+        <p:nvSpPr>
+          <p:cNvPr id="32" name="Text 26"/>
+          <p:cNvSpPr/>
+          <p:nvPr/>
+        </p:nvSpPr>
+        <p:spPr>
+          <a:xfrm>
+            <a:off x="7132320" y="3794760"/>
+            <a:ext cx="1828800" cy="731520"/>
           </a:xfrm>
           <a:prstGeom prst="rect">
             <a:avLst/>
@@ -3155,369 +3528,24 @@
             <a:r>
               <a:rPr lang="en-US" sz="1000" dirty="0">
                 <a:solidFill>
-                  <a:srgbClr val="475569"/>
-                </a:solidFill>
-                <a:latin typeface="Calibri" pitchFamily="34" charset="0"/>
-                <a:ea typeface="Calibri" pitchFamily="34" charset="-122"/>
-                <a:cs typeface="Calibri" pitchFamily="34" charset="-120"/>
-              </a:rPr>
-              <a:t>Feature branches per agent. PR-based code review across 4 team members. CLAUDE.md served as the AI context file for Claude Code in the repo.</a:t>
-            </a:r>
-            <a:endParaRPr lang="en-US" sz="1000" dirty="0"/>
-          </a:p>
-        </p:txBody>
-      </p:sp>
-      <p:sp>
-        <p:nvSpPr>
-          <p:cNvPr id="25" name="Shape 23"/>
-          <p:cNvSpPr/>
-          <p:nvPr/>
-        </p:nvSpPr>
-        <p:spPr>
-          <a:xfrm>
-            <a:off x="4846320" y="2240280"/>
-            <a:ext cx="4114800" cy="1188720"/>
-          </a:xfrm>
-          <a:prstGeom prst="rect">
-            <a:avLst/>
-          </a:prstGeom>
-          <a:solidFill>
-            <a:srgbClr val="FFFFFF"/>
-          </a:solidFill>
-          <a:ln/>
-          <a:effectLst>
-            <a:outerShdw blurRad="101600" dist="25400" dir="8100000" algn="bl" rotWithShape="0">
-              <a:srgbClr val="000000">
-                <a:alpha val="10000"/>
-              </a:srgbClr>
-            </a:outerShdw>
-          </a:effectLst>
-        </p:spPr>
-        <p:txBody>
-          <a:bodyPr/>
-          <a:lstStyle/>
-          <a:p>
-            <a:endParaRPr lang="en-US"/>
-          </a:p>
-        </p:txBody>
-      </p:sp>
-      <p:sp>
-        <p:nvSpPr>
-          <p:cNvPr id="26" name="Shape 24"/>
-          <p:cNvSpPr/>
-          <p:nvPr/>
-        </p:nvSpPr>
-        <p:spPr>
-          <a:xfrm>
-            <a:off x="4846320" y="2240280"/>
-            <a:ext cx="54864" cy="1188720"/>
-          </a:xfrm>
-          <a:prstGeom prst="rect">
-            <a:avLst/>
-          </a:prstGeom>
-          <a:solidFill>
-            <a:srgbClr val="00C2C7"/>
-          </a:solidFill>
-          <a:ln/>
-        </p:spPr>
-        <p:txBody>
-          <a:bodyPr/>
-          <a:lstStyle/>
-          <a:p>
-            <a:endParaRPr lang="en-US"/>
-          </a:p>
-        </p:txBody>
-      </p:sp>
-      <p:sp>
-        <p:nvSpPr>
-          <p:cNvPr id="27" name="Text 25"/>
-          <p:cNvSpPr/>
-          <p:nvPr/>
-        </p:nvSpPr>
-        <p:spPr>
-          <a:xfrm>
-            <a:off x="5010912" y="2313432"/>
-            <a:ext cx="457200" cy="274320"/>
-          </a:xfrm>
-          <a:prstGeom prst="rect">
-            <a:avLst/>
-          </a:prstGeom>
-          <a:noFill/>
-          <a:ln/>
-        </p:spPr>
-        <p:txBody>
-          <a:bodyPr wrap="square" lIns="0" tIns="0" rIns="0" bIns="0" rtlCol="0" anchor="ctr"/>
-          <a:lstStyle/>
-          <a:p>
-            <a:pPr marL="0" indent="0">
-              <a:buNone/>
-            </a:pPr>
-            <a:r>
-              <a:rPr lang="en-US" sz="1600" b="1" dirty="0">
-                <a:solidFill>
-                  <a:srgbClr val="00C2C7"/>
-                </a:solidFill>
-                <a:latin typeface="Calibri" pitchFamily="34" charset="0"/>
-                <a:ea typeface="Calibri" pitchFamily="34" charset="-122"/>
-                <a:cs typeface="Calibri" pitchFamily="34" charset="-120"/>
-              </a:rPr>
-              <a:t>05</a:t>
-            </a:r>
-            <a:endParaRPr lang="en-US" sz="1600" dirty="0"/>
-          </a:p>
-        </p:txBody>
-      </p:sp>
-      <p:sp>
-        <p:nvSpPr>
-          <p:cNvPr id="28" name="Text 26"/>
-          <p:cNvSpPr/>
-          <p:nvPr/>
-        </p:nvSpPr>
-        <p:spPr>
-          <a:xfrm>
-            <a:off x="5010912" y="2606040"/>
-            <a:ext cx="3749040" cy="274320"/>
-          </a:xfrm>
-          <a:prstGeom prst="rect">
-            <a:avLst/>
-          </a:prstGeom>
-          <a:noFill/>
-          <a:ln/>
-        </p:spPr>
-        <p:txBody>
-          <a:bodyPr wrap="square" lIns="0" tIns="0" rIns="0" bIns="0" rtlCol="0" anchor="ctr"/>
-          <a:lstStyle/>
-          <a:p>
-            <a:pPr marL="0" indent="0">
-              <a:buNone/>
-            </a:pPr>
-            <a:r>
-              <a:rPr lang="en-US" sz="1200" b="1" dirty="0">
-                <a:solidFill>
-                  <a:srgbClr val="1E293B"/>
-                </a:solidFill>
-                <a:latin typeface="Calibri" pitchFamily="34" charset="0"/>
-                <a:ea typeface="Calibri" pitchFamily="34" charset="-122"/>
-                <a:cs typeface="Calibri" pitchFamily="34" charset="-120"/>
-              </a:rPr>
-              <a:t>Iterative Agent Testing</a:t>
-            </a:r>
-            <a:endParaRPr lang="en-US" sz="1200" dirty="0"/>
-          </a:p>
-        </p:txBody>
-      </p:sp>
-      <p:sp>
-        <p:nvSpPr>
-          <p:cNvPr id="29" name="Text 27"/>
-          <p:cNvSpPr/>
-          <p:nvPr/>
-        </p:nvSpPr>
-        <p:spPr>
-          <a:xfrm>
-            <a:off x="5010912" y="2907792"/>
-            <a:ext cx="3749040" cy="457200"/>
-          </a:xfrm>
-          <a:prstGeom prst="rect">
-            <a:avLst/>
-          </a:prstGeom>
-          <a:noFill/>
-          <a:ln/>
-        </p:spPr>
-        <p:txBody>
-          <a:bodyPr wrap="square" lIns="0" tIns="0" rIns="0" bIns="0" rtlCol="0" anchor="ctr"/>
-          <a:lstStyle/>
-          <a:p>
-            <a:pPr marL="0" indent="0">
-              <a:buNone/>
-            </a:pPr>
+                  <a:srgbClr val="C084FC"/>
+                </a:solidFill>
+                <a:latin typeface="Calibri" pitchFamily="34" charset="0"/>
+                <a:ea typeface="Calibri" pitchFamily="34" charset="-122"/>
+                <a:cs typeface="Calibri" pitchFamily="34" charset="-120"/>
+              </a:rPr>
+              <a:t>· </a:t>
+            </a:r>
             <a:r>
               <a:rPr lang="en-US" sz="1000" dirty="0">
                 <a:solidFill>
-                  <a:srgbClr val="475569"/>
-                </a:solidFill>
-                <a:latin typeface="Calibri" pitchFamily="34" charset="0"/>
-                <a:ea typeface="Calibri" pitchFamily="34" charset="-122"/>
-                <a:cs typeface="Calibri" pitchFamily="34" charset="-120"/>
-              </a:rPr>
-              <a:t>ADK dev server + per-agent log files in SuperAgent/logs/agents/. Each agent validated independently before integration into SuperAgent.</a:t>
-            </a:r>
-            <a:endParaRPr lang="en-US" sz="1000" dirty="0"/>
-          </a:p>
-        </p:txBody>
-      </p:sp>
-      <p:sp>
-        <p:nvSpPr>
-          <p:cNvPr id="30" name="Shape 28"/>
-          <p:cNvSpPr/>
-          <p:nvPr/>
-        </p:nvSpPr>
-        <p:spPr>
-          <a:xfrm>
-            <a:off x="4846320" y="3566160"/>
-            <a:ext cx="4114800" cy="1188720"/>
-          </a:xfrm>
-          <a:prstGeom prst="rect">
-            <a:avLst/>
-          </a:prstGeom>
-          <a:solidFill>
-            <a:srgbClr val="FFFFFF"/>
-          </a:solidFill>
-          <a:ln/>
-          <a:effectLst>
-            <a:outerShdw blurRad="101600" dist="25400" dir="8100000" algn="bl" rotWithShape="0">
-              <a:srgbClr val="000000">
-                <a:alpha val="10000"/>
-              </a:srgbClr>
-            </a:outerShdw>
-          </a:effectLst>
-        </p:spPr>
-        <p:txBody>
-          <a:bodyPr/>
-          <a:lstStyle/>
-          <a:p>
-            <a:endParaRPr lang="en-US"/>
-          </a:p>
-        </p:txBody>
-      </p:sp>
-      <p:sp>
-        <p:nvSpPr>
-          <p:cNvPr id="31" name="Shape 29"/>
-          <p:cNvSpPr/>
-          <p:nvPr/>
-        </p:nvSpPr>
-        <p:spPr>
-          <a:xfrm>
-            <a:off x="4846320" y="3566160"/>
-            <a:ext cx="54864" cy="1188720"/>
-          </a:xfrm>
-          <a:prstGeom prst="rect">
-            <a:avLst/>
-          </a:prstGeom>
-          <a:solidFill>
-            <a:srgbClr val="00C2C7"/>
-          </a:solidFill>
-          <a:ln/>
-        </p:spPr>
-        <p:txBody>
-          <a:bodyPr/>
-          <a:lstStyle/>
-          <a:p>
-            <a:endParaRPr lang="en-US"/>
-          </a:p>
-        </p:txBody>
-      </p:sp>
-      <p:sp>
-        <p:nvSpPr>
-          <p:cNvPr id="32" name="Text 30"/>
-          <p:cNvSpPr/>
-          <p:nvPr/>
-        </p:nvSpPr>
-        <p:spPr>
-          <a:xfrm>
-            <a:off x="5010912" y="3639312"/>
-            <a:ext cx="457200" cy="274320"/>
-          </a:xfrm>
-          <a:prstGeom prst="rect">
-            <a:avLst/>
-          </a:prstGeom>
-          <a:noFill/>
-          <a:ln/>
-        </p:spPr>
-        <p:txBody>
-          <a:bodyPr wrap="square" lIns="0" tIns="0" rIns="0" bIns="0" rtlCol="0" anchor="ctr"/>
-          <a:lstStyle/>
-          <a:p>
-            <a:pPr marL="0" indent="0">
-              <a:buNone/>
-            </a:pPr>
-            <a:r>
-              <a:rPr lang="en-US" sz="1600" b="1" dirty="0">
-                <a:solidFill>
-                  <a:srgbClr val="00C2C7"/>
-                </a:solidFill>
-                <a:latin typeface="Calibri" pitchFamily="34" charset="0"/>
-                <a:ea typeface="Calibri" pitchFamily="34" charset="-122"/>
-                <a:cs typeface="Calibri" pitchFamily="34" charset="-120"/>
-              </a:rPr>
-              <a:t>06</a:t>
-            </a:r>
-            <a:endParaRPr lang="en-US" sz="1600" dirty="0"/>
-          </a:p>
-        </p:txBody>
-      </p:sp>
-      <p:sp>
-        <p:nvSpPr>
-          <p:cNvPr id="33" name="Text 31"/>
-          <p:cNvSpPr/>
-          <p:nvPr/>
-        </p:nvSpPr>
-        <p:spPr>
-          <a:xfrm>
-            <a:off x="5010912" y="3931920"/>
-            <a:ext cx="3749040" cy="274320"/>
-          </a:xfrm>
-          <a:prstGeom prst="rect">
-            <a:avLst/>
-          </a:prstGeom>
-          <a:noFill/>
-          <a:ln/>
-        </p:spPr>
-        <p:txBody>
-          <a:bodyPr wrap="square" lIns="0" tIns="0" rIns="0" bIns="0" rtlCol="0" anchor="ctr"/>
-          <a:lstStyle/>
-          <a:p>
-            <a:pPr marL="0" indent="0">
-              <a:buNone/>
-            </a:pPr>
-            <a:r>
-              <a:rPr lang="en-US" sz="1200" b="1" dirty="0">
-                <a:solidFill>
-                  <a:srgbClr val="1E293B"/>
-                </a:solidFill>
-                <a:latin typeface="Calibri" pitchFamily="34" charset="0"/>
-                <a:ea typeface="Calibri" pitchFamily="34" charset="-122"/>
-                <a:cs typeface="Calibri" pitchFamily="34" charset="-120"/>
-              </a:rPr>
-              <a:t>Spec-Driven Development</a:t>
-            </a:r>
-            <a:endParaRPr lang="en-US" sz="1200" dirty="0"/>
-          </a:p>
-        </p:txBody>
-      </p:sp>
-      <p:sp>
-        <p:nvSpPr>
-          <p:cNvPr id="34" name="Text 32"/>
-          <p:cNvSpPr/>
-          <p:nvPr/>
-        </p:nvSpPr>
-        <p:spPr>
-          <a:xfrm>
-            <a:off x="5010912" y="4233672"/>
-            <a:ext cx="3749040" cy="457200"/>
-          </a:xfrm>
-          <a:prstGeom prst="rect">
-            <a:avLst/>
-          </a:prstGeom>
-          <a:noFill/>
-          <a:ln/>
-        </p:spPr>
-        <p:txBody>
-          <a:bodyPr wrap="square" lIns="0" tIns="0" rIns="0" bIns="0" rtlCol="0" anchor="ctr"/>
-          <a:lstStyle/>
-          <a:p>
-            <a:pPr marL="0" indent="0">
-              <a:buNone/>
-            </a:pPr>
-            <a:r>
-              <a:rPr lang="en-US" sz="1000" dirty="0">
-                <a:solidFill>
-                  <a:srgbClr val="475569"/>
-                </a:solidFill>
-                <a:latin typeface="Calibri" pitchFamily="34" charset="0"/>
-                <a:ea typeface="Calibri" pitchFamily="34" charset="-122"/>
-                <a:cs typeface="Calibri" pitchFamily="34" charset="-120"/>
-              </a:rPr>
-              <a:t>AGENTS.md and Openspec files defined tool contracts before implementation. Prevented agent drift — each agent knew exactly what to own and what not to touch.</a:t>
+                  <a:srgbClr val="E8F4F8"/>
+                </a:solidFill>
+                <a:latin typeface="Calibri" pitchFamily="34" charset="0"/>
+                <a:ea typeface="Calibri" pitchFamily="34" charset="-122"/>
+                <a:cs typeface="Calibri" pitchFamily="34" charset="-120"/>
+              </a:rPr>
+              <a:t>Google AI Studio for prompt engineering and evals</a:t>
             </a:r>
             <a:endParaRPr lang="en-US" sz="1000" dirty="0"/>
           </a:p>
@@ -8778,7 +8806,7 @@
         <p:spPr>
           <a:xfrm>
             <a:off x="3200400" y="822960"/>
-            <a:ext cx="2743200" cy="868680"/>
+            <a:ext cx="2743200" cy="755063"/>
           </a:xfrm>
           <a:prstGeom prst="rect">
             <a:avLst/>
@@ -8892,7 +8920,7 @@
         <p:spPr>
           <a:xfrm>
             <a:off x="274320" y="1920240"/>
-            <a:ext cx="1572768" cy="868680"/>
+            <a:ext cx="1572768" cy="676656"/>
           </a:xfrm>
           <a:prstGeom prst="rect">
             <a:avLst/>
@@ -9019,7 +9047,7 @@
         <p:spPr>
           <a:xfrm>
             <a:off x="1993392" y="1920240"/>
-            <a:ext cx="1572768" cy="868680"/>
+            <a:ext cx="1572768" cy="676656"/>
           </a:xfrm>
           <a:prstGeom prst="rect">
             <a:avLst/>
@@ -9146,7 +9174,7 @@
         <p:spPr>
           <a:xfrm>
             <a:off x="3712464" y="1920240"/>
-            <a:ext cx="1572768" cy="868680"/>
+            <a:ext cx="1572768" cy="676656"/>
           </a:xfrm>
           <a:prstGeom prst="rect">
             <a:avLst/>
@@ -9273,7 +9301,7 @@
         <p:spPr>
           <a:xfrm>
             <a:off x="5431536" y="1920240"/>
-            <a:ext cx="1572768" cy="868680"/>
+            <a:ext cx="1572768" cy="676656"/>
           </a:xfrm>
           <a:prstGeom prst="rect">
             <a:avLst/>
@@ -9400,7 +9428,7 @@
         <p:spPr>
           <a:xfrm>
             <a:off x="7150608" y="1920240"/>
-            <a:ext cx="1572768" cy="868680"/>
+            <a:ext cx="1572768" cy="676656"/>
           </a:xfrm>
           <a:prstGeom prst="rect">
             <a:avLst/>
@@ -10227,6 +10255,72 @@
               <a:t>Zero hallucination on critical data  ·  Temperature-stratified agents (0.0 for deterministic, 0.7 for conversational)  ·  Router-only SuperAgent (never generates user-facing text)</a:t>
             </a:r>
             <a:endParaRPr lang="en-US" sz="1100" dirty="0"/>
+          </a:p>
+        </p:txBody>
+      </p:sp>
+      <p:sp>
+        <p:nvSpPr>
+          <p:cNvPr id="50" name="Shape 8">
+            <a:extLst>
+              <a:ext uri="{FF2B5EF4-FFF2-40B4-BE49-F238E27FC236}">
+                <a16:creationId xmlns:a16="http://schemas.microsoft.com/office/drawing/2014/main" id="{351429CD-C9FB-EE35-CE8C-7EEA3D6CD067}"/>
+              </a:ext>
+            </a:extLst>
+          </p:cNvPr>
+          <p:cNvSpPr/>
+          <p:nvPr/>
+        </p:nvSpPr>
+        <p:spPr>
+          <a:xfrm rot="5400000">
+            <a:off x="4384549" y="-1728898"/>
+            <a:ext cx="45719" cy="6876290"/>
+          </a:xfrm>
+          <a:prstGeom prst="rect">
+            <a:avLst/>
+          </a:prstGeom>
+          <a:solidFill>
+            <a:srgbClr val="94A3B8"/>
+          </a:solidFill>
+          <a:ln/>
+        </p:spPr>
+        <p:txBody>
+          <a:bodyPr/>
+          <a:lstStyle/>
+          <a:p>
+            <a:endParaRPr lang="en-US"/>
+          </a:p>
+        </p:txBody>
+      </p:sp>
+      <p:sp>
+        <p:nvSpPr>
+          <p:cNvPr id="51" name="Shape 8">
+            <a:extLst>
+              <a:ext uri="{FF2B5EF4-FFF2-40B4-BE49-F238E27FC236}">
+                <a16:creationId xmlns:a16="http://schemas.microsoft.com/office/drawing/2014/main" id="{DEF6A486-C3ED-A7EE-B037-8C05E917179F}"/>
+              </a:ext>
+            </a:extLst>
+          </p:cNvPr>
+          <p:cNvSpPr/>
+          <p:nvPr/>
+        </p:nvSpPr>
+        <p:spPr>
+          <a:xfrm rot="5400000">
+            <a:off x="4384548" y="-649225"/>
+            <a:ext cx="45719" cy="6876290"/>
+          </a:xfrm>
+          <a:prstGeom prst="rect">
+            <a:avLst/>
+          </a:prstGeom>
+          <a:solidFill>
+            <a:srgbClr val="94A3B8"/>
+          </a:solidFill>
+          <a:ln/>
+        </p:spPr>
+        <p:txBody>
+          <a:bodyPr/>
+          <a:lstStyle/>
+          <a:p>
+            <a:endParaRPr lang="en-US"/>
           </a:p>
         </p:txBody>
       </p:sp>
@@ -11008,7 +11102,7 @@
         <p:spPr>
           <a:xfrm>
             <a:off x="685800" y="3163824"/>
-            <a:ext cx="3657600" cy="228600"/>
+            <a:ext cx="1371600" cy="182880"/>
           </a:xfrm>
           <a:prstGeom prst="rect">
             <a:avLst/>
@@ -11032,7 +11126,7 @@
                 <a:ea typeface="Calibri" pitchFamily="34" charset="-122"/>
                 <a:cs typeface="Calibri" pitchFamily="34" charset="-120"/>
               </a:rPr>
-              <a:t>React 19 + Vite + Tailwind</a:t>
+              <a:t>React 19</a:t>
             </a:r>
             <a:endParaRPr lang="en-US" sz="1300" dirty="0"/>
           </a:p>
@@ -12042,7 +12136,7 @@
         </p:nvSpPr>
         <p:spPr>
           <a:xfrm>
-            <a:off x="8686800" y="4800600"/>
+            <a:off x="8746901" y="4543023"/>
             <a:ext cx="365760" cy="228600"/>
           </a:xfrm>
           <a:prstGeom prst="rect">
@@ -12103,7 +12197,7 @@
                 <a:ea typeface="Calibri" pitchFamily="34" charset="-122"/>
                 <a:cs typeface="Calibri" pitchFamily="34" charset="-120"/>
               </a:rPr>
-              <a:t>Live Demo</a:t>
+              <a:t>Conversation Demo</a:t>
             </a:r>
             <a:endParaRPr lang="en-US" sz="3400" dirty="0"/>
           </a:p>
@@ -12169,7 +12263,7 @@
                 <a:ea typeface="Calibri" pitchFamily="34" charset="-122"/>
                 <a:cs typeface="Calibri" pitchFamily="34" charset="-120"/>
               </a:rPr>
-              <a:t>Scenario: Mid-market prospect inquires about multi-location connectivity</a:t>
+              <a:t>Scenario: prospect inquires about connectivity</a:t>
             </a:r>
             <a:endParaRPr lang="en-US" sz="1300" dirty="0"/>
           </a:p>
@@ -12183,7 +12277,7 @@
         </p:nvSpPr>
         <p:spPr>
           <a:xfrm>
-            <a:off x="4114800" y="1325880"/>
+            <a:off x="4174901" y="1068303"/>
             <a:ext cx="4572000" cy="594360"/>
           </a:xfrm>
           <a:prstGeom prst="rect">
@@ -12217,7 +12311,7 @@
         </p:nvSpPr>
         <p:spPr>
           <a:xfrm>
-            <a:off x="4251960" y="1389888"/>
+            <a:off x="4312061" y="1132311"/>
             <a:ext cx="4343400" cy="475488"/>
           </a:xfrm>
           <a:prstGeom prst="rect">
@@ -12230,9 +12324,26 @@
           <a:bodyPr wrap="square" lIns="0" tIns="0" rIns="0" bIns="0" rtlCol="0" anchor="ctr"/>
           <a:lstStyle/>
           <a:p>
-            <a:pPr marL="0" indent="0">
-              <a:buNone/>
-            </a:pPr>
+            <a:endParaRPr lang="en-US" sz="1000" dirty="0">
+              <a:solidFill>
+                <a:srgbClr val="FFFFFF"/>
+              </a:solidFill>
+              <a:latin typeface="Calibri" pitchFamily="34" charset="0"/>
+              <a:ea typeface="Calibri" pitchFamily="34" charset="-122"/>
+              <a:cs typeface="Calibri" pitchFamily="34" charset="-120"/>
+            </a:endParaRPr>
+          </a:p>
+          <a:p>
+            <a:endParaRPr lang="en-US" sz="1000" dirty="0">
+              <a:solidFill>
+                <a:srgbClr val="FFFFFF"/>
+              </a:solidFill>
+              <a:latin typeface="Calibri" pitchFamily="34" charset="0"/>
+              <a:ea typeface="Calibri" pitchFamily="34" charset="-122"/>
+              <a:cs typeface="Calibri" pitchFamily="34" charset="-120"/>
+            </a:endParaRPr>
+          </a:p>
+          <a:p>
             <a:r>
               <a:rPr lang="en-US" sz="1000" dirty="0">
                 <a:solidFill>
@@ -12242,8 +12353,20 @@
                 <a:ea typeface="Calibri" pitchFamily="34" charset="-122"/>
                 <a:cs typeface="Calibri" pitchFamily="34" charset="-120"/>
               </a:rPr>
-              <a:t>User:  Hi, I need fiber connectivity for our 5 offices in the Philadelphia metro area — can you help?</a:t>
-            </a:r>
+              <a:t>User:  I need internet for my ice-cream shop Mango Mango . I am at 123 Main Street Philadelphia PA 19103</a:t>
+            </a:r>
+          </a:p>
+          <a:p>
+            <a:br>
+              <a:rPr lang="en-US" sz="1000" dirty="0">
+                <a:solidFill>
+                  <a:srgbClr val="FFFFFF"/>
+                </a:solidFill>
+                <a:latin typeface="Calibri" pitchFamily="34" charset="0"/>
+                <a:ea typeface="Calibri" pitchFamily="34" charset="-122"/>
+                <a:cs typeface="Calibri" pitchFamily="34" charset="-120"/>
+              </a:rPr>
+            </a:br>
             <a:endParaRPr lang="en-US" sz="1000" dirty="0"/>
           </a:p>
         </p:txBody>
@@ -12256,7 +12379,7 @@
         </p:nvSpPr>
         <p:spPr>
           <a:xfrm>
-            <a:off x="457200" y="2029968"/>
+            <a:off x="517301" y="1772391"/>
             <a:ext cx="4572000" cy="594360"/>
           </a:xfrm>
           <a:prstGeom prst="rect">
@@ -12290,22 +12413,19 @@
         </p:nvSpPr>
         <p:spPr>
           <a:xfrm>
-            <a:off x="594360" y="2093976"/>
-            <a:ext cx="4343400" cy="475488"/>
-          </a:xfrm>
-          <a:prstGeom prst="rect">
-            <a:avLst/>
-          </a:prstGeom>
-          <a:noFill/>
-          <a:ln/>
-        </p:spPr>
-        <p:txBody>
-          <a:bodyPr wrap="square" lIns="0" tIns="0" rIns="0" bIns="0" rtlCol="0" anchor="ctr"/>
-          <a:lstStyle/>
-          <a:p>
-            <a:pPr marL="0" indent="0">
-              <a:buNone/>
-            </a:pPr>
+            <a:off x="654461" y="1749252"/>
+            <a:ext cx="4709375" cy="736371"/>
+          </a:xfrm>
+          <a:prstGeom prst="rect">
+            <a:avLst/>
+          </a:prstGeom>
+          <a:noFill/>
+          <a:ln/>
+        </p:spPr>
+        <p:txBody>
+          <a:bodyPr wrap="square" lIns="0" tIns="0" rIns="0" bIns="0" rtlCol="0" anchor="ctr"/>
+          <a:lstStyle/>
+          <a:p>
             <a:r>
               <a:rPr lang="en-US" sz="1000" dirty="0">
                 <a:solidFill>
@@ -12315,8 +12435,23 @@
                 <a:ea typeface="Calibri" pitchFamily="34" charset="-122"/>
                 <a:cs typeface="Calibri" pitchFamily="34" charset="-120"/>
               </a:rPr>
-              <a:t>Agent → DiscoveryAgent:  Happy to help! Let me get some details. What's your company name and the primary location you'd like to start with?</a:t>
-            </a:r>
+              <a:t>Agent → DiscoveryAgent:  We're more than happy to have you as a customer! I've successfully registered Mango Mango at 123 Main Street in Philadelphia in our system.</a:t>
+            </a:r>
+          </a:p>
+          <a:p>
+            <a:r>
+              <a:rPr lang="en-US" sz="1000" dirty="0">
+                <a:solidFill>
+                  <a:srgbClr val="E8F4F8"/>
+                </a:solidFill>
+                <a:latin typeface="Calibri" pitchFamily="34" charset="0"/>
+                <a:ea typeface="Calibri" pitchFamily="34" charset="-122"/>
+                <a:cs typeface="Calibri" pitchFamily="34" charset="-120"/>
+              </a:rPr>
+              <a:t>To help me find the best internet options for your ice cream shop, could you tell me a bit more about what you're looking for? </a:t>
+            </a:r>
+          </a:p>
+          <a:p>
             <a:endParaRPr lang="en-US" sz="1000" dirty="0"/>
           </a:p>
         </p:txBody>
@@ -12329,7 +12464,7 @@
         </p:nvSpPr>
         <p:spPr>
           <a:xfrm>
-            <a:off x="4114800" y="2734056"/>
+            <a:off x="4174901" y="2476479"/>
             <a:ext cx="4572000" cy="594360"/>
           </a:xfrm>
           <a:prstGeom prst="rect">
@@ -12363,7 +12498,7 @@
         </p:nvSpPr>
         <p:spPr>
           <a:xfrm>
-            <a:off x="4251960" y="2798064"/>
+            <a:off x="4312061" y="2540487"/>
             <a:ext cx="4343400" cy="475488"/>
           </a:xfrm>
           <a:prstGeom prst="rect">
@@ -12376,9 +12511,6 @@
           <a:bodyPr wrap="square" lIns="0" tIns="0" rIns="0" bIns="0" rtlCol="0" anchor="ctr"/>
           <a:lstStyle/>
           <a:p>
-            <a:pPr marL="0" indent="0">
-              <a:buNone/>
-            </a:pPr>
             <a:r>
               <a:rPr lang="en-US" sz="1000" dirty="0">
                 <a:solidFill>
@@ -12388,7 +12520,29 @@
                 <a:ea typeface="Calibri" pitchFamily="34" charset="-122"/>
                 <a:cs typeface="Calibri" pitchFamily="34" charset="-120"/>
               </a:rPr>
-              <a:t>User:  Acme Logistics. Start with our HQ at 200 Commerce Dr, Cherry Hill, NJ.</a:t>
+              <a:t>User:  Brand new location and new internet asap . I am Mr Mumbo Jumbo and </a:t>
+            </a:r>
+            <a:r>
+              <a:rPr lang="en-US" sz="1000" dirty="0" err="1">
+                <a:solidFill>
+                  <a:srgbClr val="FFFFFF"/>
+                </a:solidFill>
+                <a:latin typeface="Calibri" pitchFamily="34" charset="0"/>
+                <a:ea typeface="Calibri" pitchFamily="34" charset="-122"/>
+                <a:cs typeface="Calibri" pitchFamily="34" charset="-120"/>
+              </a:rPr>
+              <a:t>i</a:t>
+            </a:r>
+            <a:r>
+              <a:rPr lang="en-US" sz="1000" dirty="0">
+                <a:solidFill>
+                  <a:srgbClr val="FFFFFF"/>
+                </a:solidFill>
+                <a:latin typeface="Calibri" pitchFamily="34" charset="0"/>
+                <a:ea typeface="Calibri" pitchFamily="34" charset="-122"/>
+                <a:cs typeface="Calibri" pitchFamily="34" charset="-120"/>
+              </a:rPr>
+              <a:t> am the manager. My email id - User@gmail.com and Phone number is 434-444-4564. My budget is $400 per month</a:t>
             </a:r>
             <a:endParaRPr lang="en-US" sz="1000" dirty="0"/>
           </a:p>
@@ -12402,8 +12556,8 @@
         </p:nvSpPr>
         <p:spPr>
           <a:xfrm>
-            <a:off x="457200" y="3438144"/>
-            <a:ext cx="4572000" cy="594360"/>
+            <a:off x="517301" y="3180567"/>
+            <a:ext cx="4100634" cy="452628"/>
           </a:xfrm>
           <a:prstGeom prst="rect">
             <a:avLst/>
@@ -12436,7 +12590,7 @@
         </p:nvSpPr>
         <p:spPr>
           <a:xfrm>
-            <a:off x="594360" y="3502152"/>
+            <a:off x="654461" y="3244575"/>
             <a:ext cx="4343400" cy="475488"/>
           </a:xfrm>
           <a:prstGeom prst="rect">
@@ -12461,7 +12615,7 @@
                 <a:ea typeface="Calibri" pitchFamily="34" charset="-122"/>
                 <a:cs typeface="Calibri" pitchFamily="34" charset="-120"/>
               </a:rPr>
-              <a:t>Agent → ServiceabilityAgent + ProductAgent:  ✓ Address verified — Fiber available. Based on 5-location, logistics profile, I recommend our Business Fiber 1Gbps with SLA. Generating a multi-site quote now…</a:t>
+              <a:t>Agent → ServiceabilityAgent + ProductAgent:  ✓ Address serviceable — Fiber available. </a:t>
             </a:r>
             <a:endParaRPr lang="en-US" sz="1000" dirty="0"/>
           </a:p>
@@ -12475,7 +12629,7 @@
         </p:nvSpPr>
         <p:spPr>
           <a:xfrm>
-            <a:off x="457200" y="4142232"/>
+            <a:off x="517301" y="4075197"/>
             <a:ext cx="4572000" cy="594360"/>
           </a:xfrm>
           <a:prstGeom prst="rect">
@@ -12509,7 +12663,7 @@
         </p:nvSpPr>
         <p:spPr>
           <a:xfrm>
-            <a:off x="594360" y="4206240"/>
+            <a:off x="598653" y="4244105"/>
             <a:ext cx="4343400" cy="475488"/>
           </a:xfrm>
           <a:prstGeom prst="rect">
@@ -12522,19 +12676,53 @@
           <a:bodyPr wrap="square" lIns="0" tIns="0" rIns="0" bIns="0" rtlCol="0" anchor="ctr"/>
           <a:lstStyle/>
           <a:p>
-            <a:pPr marL="0" indent="0">
-              <a:buNone/>
-            </a:pPr>
             <a:r>
               <a:rPr lang="en-US" sz="1000" dirty="0">
                 <a:solidFill>
-                  <a:srgbClr val="22D3A5"/>
-                </a:solidFill>
-                <a:latin typeface="Calibri" pitchFamily="34" charset="0"/>
-                <a:ea typeface="Calibri" pitchFamily="34" charset="-122"/>
-                <a:cs typeface="Calibri" pitchFamily="34" charset="-120"/>
-              </a:rPr>
-              <a:t>Agent → OfferManagementAgent:  Here's your quote: 5-site Business Fiber 1Gbps, 36-month term — $4,850/mo with bundled SLA &amp; 15% multi-site discount.</a:t>
+                  <a:srgbClr val="E8F4F8"/>
+                </a:solidFill>
+                <a:latin typeface="Calibri" pitchFamily="34" charset="0"/>
+                <a:cs typeface="Calibri" pitchFamily="34" charset="-120"/>
+              </a:rPr>
+              <a:t>Agent → OfferManagementAgent:  Based on the serviceability check for your location at 123 Main Street, Philadelphia, here are the available products across our categories..</a:t>
+            </a:r>
+          </a:p>
+        </p:txBody>
+      </p:sp>
+      <p:sp>
+        <p:nvSpPr>
+          <p:cNvPr id="16" name="Text 14"/>
+          <p:cNvSpPr/>
+          <p:nvPr/>
+        </p:nvSpPr>
+        <p:spPr>
+          <a:xfrm>
+            <a:off x="517301" y="4719849"/>
+            <a:ext cx="8229600" cy="274320"/>
+          </a:xfrm>
+          <a:prstGeom prst="rect">
+            <a:avLst/>
+          </a:prstGeom>
+          <a:noFill/>
+          <a:ln/>
+        </p:spPr>
+        <p:txBody>
+          <a:bodyPr wrap="square" rtlCol="0" anchor="ctr"/>
+          <a:lstStyle/>
+          <a:p>
+            <a:pPr marL="0" indent="0" algn="ctr">
+              <a:buNone/>
+            </a:pPr>
+            <a:r>
+              <a:rPr lang="en-US" sz="1000" i="1" dirty="0">
+                <a:solidFill>
+                  <a:srgbClr val="94A3B8"/>
+                </a:solidFill>
+                <a:latin typeface="Calibri" pitchFamily="34" charset="0"/>
+                <a:ea typeface="Calibri" pitchFamily="34" charset="-122"/>
+                <a:cs typeface="Calibri" pitchFamily="34" charset="-120"/>
+              </a:rPr>
+              <a:t>→  Super Agent and Sub agent routes each turn automatically — user sees one seamless conversation</a:t>
             </a:r>
             <a:endParaRPr lang="en-US" sz="1000" dirty="0"/>
           </a:p>
@@ -12542,39 +12730,117 @@
       </p:sp>
       <p:sp>
         <p:nvSpPr>
-          <p:cNvPr id="16" name="Text 14"/>
-          <p:cNvSpPr/>
-          <p:nvPr/>
-        </p:nvSpPr>
-        <p:spPr>
-          <a:xfrm>
-            <a:off x="457200" y="4754880"/>
-            <a:ext cx="8229600" cy="274320"/>
-          </a:xfrm>
-          <a:prstGeom prst="rect">
-            <a:avLst/>
-          </a:prstGeom>
-          <a:noFill/>
-          <a:ln/>
-        </p:spPr>
-        <p:txBody>
-          <a:bodyPr wrap="square" rtlCol="0" anchor="ctr"/>
-          <a:lstStyle/>
-          <a:p>
-            <a:pPr marL="0" indent="0" algn="ctr">
-              <a:buNone/>
-            </a:pPr>
-            <a:r>
-              <a:rPr lang="en-US" sz="1000" i="1" dirty="0">
-                <a:solidFill>
-                  <a:srgbClr val="94A3B8"/>
-                </a:solidFill>
-                <a:latin typeface="Calibri" pitchFamily="34" charset="0"/>
-                <a:ea typeface="Calibri" pitchFamily="34" charset="-122"/>
-                <a:cs typeface="Calibri" pitchFamily="34" charset="-120"/>
-              </a:rPr>
-              <a:t>→  SuperAgent routes each turn automatically — user sees one seamless conversation</a:t>
-            </a:r>
+          <p:cNvPr id="18" name="Shape 8">
+            <a:extLst>
+              <a:ext uri="{FF2B5EF4-FFF2-40B4-BE49-F238E27FC236}">
+                <a16:creationId xmlns:a16="http://schemas.microsoft.com/office/drawing/2014/main" id="{4DF64D9A-4616-9DF9-085C-1E4AB4E28D1F}"/>
+              </a:ext>
+            </a:extLst>
+          </p:cNvPr>
+          <p:cNvSpPr/>
+          <p:nvPr/>
+        </p:nvSpPr>
+        <p:spPr>
+          <a:xfrm>
+            <a:off x="4224271" y="3569187"/>
+            <a:ext cx="4572000" cy="594360"/>
+          </a:xfrm>
+          <a:prstGeom prst="rect">
+            <a:avLst/>
+          </a:prstGeom>
+          <a:solidFill>
+            <a:srgbClr val="028090"/>
+          </a:solidFill>
+          <a:ln/>
+          <a:effectLst>
+            <a:outerShdw blurRad="63500" dist="25400" dir="8100000" algn="bl" rotWithShape="0">
+              <a:srgbClr val="000000">
+                <a:alpha val="30000"/>
+              </a:srgbClr>
+            </a:outerShdw>
+          </a:effectLst>
+        </p:spPr>
+        <p:txBody>
+          <a:bodyPr/>
+          <a:lstStyle/>
+          <a:p>
+            <a:endParaRPr lang="en-US"/>
+          </a:p>
+        </p:txBody>
+      </p:sp>
+      <p:sp>
+        <p:nvSpPr>
+          <p:cNvPr id="19" name="Text 9">
+            <a:extLst>
+              <a:ext uri="{FF2B5EF4-FFF2-40B4-BE49-F238E27FC236}">
+                <a16:creationId xmlns:a16="http://schemas.microsoft.com/office/drawing/2014/main" id="{6197154D-2F2F-0444-9AAB-FE2683DED50B}"/>
+              </a:ext>
+            </a:extLst>
+          </p:cNvPr>
+          <p:cNvSpPr/>
+          <p:nvPr/>
+        </p:nvSpPr>
+        <p:spPr>
+          <a:xfrm>
+            <a:off x="4361431" y="3633195"/>
+            <a:ext cx="4343400" cy="475488"/>
+          </a:xfrm>
+          <a:prstGeom prst="rect">
+            <a:avLst/>
+          </a:prstGeom>
+          <a:noFill/>
+          <a:ln/>
+        </p:spPr>
+        <p:txBody>
+          <a:bodyPr wrap="square" lIns="0" tIns="0" rIns="0" bIns="0" rtlCol="0" anchor="ctr"/>
+          <a:lstStyle/>
+          <a:p>
+            <a:endParaRPr lang="en-US" sz="1000" dirty="0">
+              <a:solidFill>
+                <a:srgbClr val="FFFFFF"/>
+              </a:solidFill>
+              <a:latin typeface="Calibri" pitchFamily="34" charset="0"/>
+              <a:ea typeface="Calibri" pitchFamily="34" charset="-122"/>
+              <a:cs typeface="Calibri" pitchFamily="34" charset="-120"/>
+            </a:endParaRPr>
+          </a:p>
+          <a:p>
+            <a:endParaRPr lang="en-US" sz="1000" dirty="0">
+              <a:solidFill>
+                <a:srgbClr val="FFFFFF"/>
+              </a:solidFill>
+              <a:latin typeface="Calibri" pitchFamily="34" charset="0"/>
+              <a:ea typeface="Calibri" pitchFamily="34" charset="-122"/>
+              <a:cs typeface="Calibri" pitchFamily="34" charset="-120"/>
+            </a:endParaRPr>
+          </a:p>
+          <a:p>
+            <a:r>
+              <a:rPr lang="en-US" sz="1000" dirty="0">
+                <a:solidFill>
+                  <a:srgbClr val="FFFFFF"/>
+                </a:solidFill>
+                <a:latin typeface="Calibri" pitchFamily="34" charset="0"/>
+                <a:ea typeface="Calibri" pitchFamily="34" charset="-122"/>
+                <a:cs typeface="Calibri" pitchFamily="34" charset="-120"/>
+              </a:rPr>
+              <a:t>User:  </a:t>
+            </a:r>
+            <a:r>
+              <a:rPr lang="en-US" sz="1000" dirty="0">
+                <a:solidFill>
+                  <a:srgbClr val="FFFFFF"/>
+                </a:solidFill>
+                <a:latin typeface="Calibri" pitchFamily="34" charset="0"/>
+                <a:cs typeface="Calibri" pitchFamily="34" charset="-120"/>
+              </a:rPr>
+              <a:t>Show me all available products - internet (fiber and non fiber) and other products at this location</a:t>
+            </a:r>
+          </a:p>
+          <a:p>
+            <a:br>
+              <a:rPr lang="en-US" sz="1000" dirty="0"/>
+            </a:br>
             <a:endParaRPr lang="en-US" sz="1000" dirty="0"/>
           </a:p>
         </p:txBody>
@@ -13836,11 +14102,11 @@
 
 <file path=ppt/slides/slide9.xml><?xml version="1.0" encoding="utf-8"?>
 <p:sld xmlns:a="http://schemas.openxmlformats.org/drawingml/2006/main" xmlns:r="http://schemas.openxmlformats.org/officeDocument/2006/relationships" xmlns:p="http://schemas.openxmlformats.org/presentationml/2006/main">
-  <p:cSld name="Slide 9">
+  <p:cSld name="Slide 10">
     <p:bg>
       <p:bgPr>
         <a:solidFill>
-          <a:srgbClr val="0D1B3E"/>
+          <a:srgbClr val="F0F6FA"/>
         </a:solidFill>
         <a:effectLst/>
       </p:bgPr>
@@ -13889,7 +14155,7 @@
                   <a:srgbClr val="94A3B8"/>
                 </a:solidFill>
               </a:rPr>
-              <a:t>9</a:t>
+              <a:t>10</a:t>
             </a:r>
             <a:endParaRPr lang="en-US" sz="900" dirty="0"/>
           </a:p>
@@ -13903,7 +14169,7 @@
         </p:nvSpPr>
         <p:spPr>
           <a:xfrm>
-            <a:off x="457200" y="182880"/>
+            <a:off x="457200" y="228600"/>
             <a:ext cx="8229600" cy="457200"/>
           </a:xfrm>
           <a:prstGeom prst="rect">
@@ -13920,17 +14186,17 @@
               <a:buNone/>
             </a:pPr>
             <a:r>
-              <a:rPr lang="en-US" sz="2800" b="1" dirty="0">
-                <a:solidFill>
-                  <a:srgbClr val="FFFFFF"/>
-                </a:solidFill>
-                <a:latin typeface="Calibri" pitchFamily="34" charset="0"/>
-                <a:ea typeface="Calibri" pitchFamily="34" charset="-122"/>
-                <a:cs typeface="Calibri" pitchFamily="34" charset="-120"/>
-              </a:rPr>
-              <a:t>Research Foundation &amp; Grounding</a:t>
-            </a:r>
-            <a:endParaRPr lang="en-US" sz="2800" dirty="0"/>
+              <a:rPr lang="en-US" sz="3000" b="1" dirty="0">
+                <a:solidFill>
+                  <a:srgbClr val="1E293B"/>
+                </a:solidFill>
+                <a:latin typeface="Calibri" pitchFamily="34" charset="0"/>
+                <a:ea typeface="Calibri" pitchFamily="34" charset="-122"/>
+                <a:cs typeface="Calibri" pitchFamily="34" charset="-120"/>
+              </a:rPr>
+              <a:t>How the Code Was Written</a:t>
+            </a:r>
+            <a:endParaRPr lang="en-US" sz="3000" dirty="0"/>
           </a:p>
         </p:txBody>
       </p:sp>
@@ -13942,7 +14208,7 @@
         </p:nvSpPr>
         <p:spPr>
           <a:xfrm>
-            <a:off x="457200" y="685800"/>
+            <a:off x="457200" y="731520"/>
             <a:ext cx="8229600" cy="54864"/>
           </a:xfrm>
           <a:prstGeom prst="rect">
@@ -13970,19 +14236,19 @@
         <p:spPr>
           <a:xfrm>
             <a:off x="457200" y="914400"/>
-            <a:ext cx="2011680" cy="3931920"/>
-          </a:xfrm>
-          <a:prstGeom prst="rect">
-            <a:avLst/>
-          </a:prstGeom>
-          <a:solidFill>
-            <a:srgbClr val="102B5A"/>
+            <a:ext cx="4114800" cy="1188720"/>
+          </a:xfrm>
+          <a:prstGeom prst="rect">
+            <a:avLst/>
+          </a:prstGeom>
+          <a:solidFill>
+            <a:srgbClr val="FFFFFF"/>
           </a:solidFill>
           <a:ln/>
           <a:effectLst>
             <a:outerShdw blurRad="101600" dist="25400" dir="8100000" algn="bl" rotWithShape="0">
               <a:srgbClr val="000000">
-                <a:alpha val="30000"/>
+                <a:alpha val="10000"/>
               </a:srgbClr>
             </a:outerShdw>
           </a:effectLst>
@@ -14004,97 +14270,34 @@
         <p:spPr>
           <a:xfrm>
             <a:off x="457200" y="914400"/>
-            <a:ext cx="2011680" cy="64008"/>
-          </a:xfrm>
-          <a:prstGeom prst="rect">
-            <a:avLst/>
-          </a:prstGeom>
-          <a:solidFill>
-            <a:srgbClr val="028090"/>
-          </a:solidFill>
-          <a:ln/>
-        </p:spPr>
-        <p:txBody>
-          <a:bodyPr/>
-          <a:lstStyle/>
-          <a:p>
-            <a:endParaRPr lang="en-US"/>
-          </a:p>
-        </p:txBody>
-      </p:sp>
-      <p:pic>
-        <p:nvPicPr>
-          <p:cNvPr id="7" name="Image 0" descr="preencoded.png"/>
-          <p:cNvPicPr>
-            <a:picLocks noChangeAspect="1"/>
-          </p:cNvPicPr>
-          <p:nvPr/>
-        </p:nvPicPr>
-        <p:blipFill>
-          <a:blip r:embed="rId3"/>
-          <a:stretch>
-            <a:fillRect/>
-          </a:stretch>
-        </p:blipFill>
-        <p:spPr>
-          <a:xfrm>
-            <a:off x="1188720" y="1097280"/>
-            <a:ext cx="502920" cy="502920"/>
-          </a:xfrm>
-          <a:prstGeom prst="rect">
-            <a:avLst/>
-          </a:prstGeom>
-        </p:spPr>
-      </p:pic>
-      <p:sp>
-        <p:nvSpPr>
-          <p:cNvPr id="8" name="Text 5"/>
-          <p:cNvSpPr/>
-          <p:nvPr/>
-        </p:nvSpPr>
-        <p:spPr>
-          <a:xfrm>
-            <a:off x="548640" y="1691640"/>
-            <a:ext cx="1828800" cy="365760"/>
-          </a:xfrm>
-          <a:prstGeom prst="rect">
-            <a:avLst/>
-          </a:prstGeom>
-          <a:noFill/>
-          <a:ln/>
-        </p:spPr>
-        <p:txBody>
-          <a:bodyPr wrap="square" lIns="0" tIns="0" rIns="0" bIns="0" rtlCol="0" anchor="ctr"/>
-          <a:lstStyle/>
-          <a:p>
-            <a:pPr marL="0" indent="0" algn="ctr">
-              <a:buNone/>
-            </a:pPr>
-            <a:r>
-              <a:rPr lang="en-US" sz="1300" b="1" dirty="0">
-                <a:solidFill>
-                  <a:srgbClr val="FFFFFF"/>
-                </a:solidFill>
-                <a:latin typeface="Calibri" pitchFamily="34" charset="0"/>
-                <a:ea typeface="Calibri" pitchFamily="34" charset="-122"/>
-                <a:cs typeface="Calibri" pitchFamily="34" charset="-120"/>
-              </a:rPr>
-              <a:t>Google ADK</a:t>
-            </a:r>
-            <a:endParaRPr lang="en-US" sz="1300" dirty="0"/>
-          </a:p>
-        </p:txBody>
-      </p:sp>
-      <p:sp>
-        <p:nvSpPr>
-          <p:cNvPr id="9" name="Text 6"/>
-          <p:cNvSpPr/>
-          <p:nvPr/>
-        </p:nvSpPr>
-        <p:spPr>
-          <a:xfrm>
-            <a:off x="548640" y="2148840"/>
-            <a:ext cx="1828800" cy="731520"/>
+            <a:ext cx="54864" cy="1188720"/>
+          </a:xfrm>
+          <a:prstGeom prst="rect">
+            <a:avLst/>
+          </a:prstGeom>
+          <a:solidFill>
+            <a:srgbClr val="00C2C7"/>
+          </a:solidFill>
+          <a:ln/>
+        </p:spPr>
+        <p:txBody>
+          <a:bodyPr/>
+          <a:lstStyle/>
+          <a:p>
+            <a:endParaRPr lang="en-US"/>
+          </a:p>
+        </p:txBody>
+      </p:sp>
+      <p:sp>
+        <p:nvSpPr>
+          <p:cNvPr id="7" name="Text 5"/>
+          <p:cNvSpPr/>
+          <p:nvPr/>
+        </p:nvSpPr>
+        <p:spPr>
+          <a:xfrm>
+            <a:off x="621792" y="987552"/>
+            <a:ext cx="457200" cy="274320"/>
           </a:xfrm>
           <a:prstGeom prst="rect">
             <a:avLst/>
@@ -14110,26 +14313,93 @@
               <a:buNone/>
             </a:pPr>
             <a:r>
+              <a:rPr lang="en-US" sz="1600" b="1" dirty="0">
+                <a:solidFill>
+                  <a:srgbClr val="00C2C7"/>
+                </a:solidFill>
+                <a:latin typeface="Calibri" pitchFamily="34" charset="0"/>
+                <a:ea typeface="Calibri" pitchFamily="34" charset="-122"/>
+                <a:cs typeface="Calibri" pitchFamily="34" charset="-120"/>
+              </a:rPr>
+              <a:t>01</a:t>
+            </a:r>
+            <a:endParaRPr lang="en-US" sz="1600" dirty="0"/>
+          </a:p>
+        </p:txBody>
+      </p:sp>
+      <p:sp>
+        <p:nvSpPr>
+          <p:cNvPr id="8" name="Text 6"/>
+          <p:cNvSpPr/>
+          <p:nvPr/>
+        </p:nvSpPr>
+        <p:spPr>
+          <a:xfrm>
+            <a:off x="621792" y="1280160"/>
+            <a:ext cx="3749040" cy="274320"/>
+          </a:xfrm>
+          <a:prstGeom prst="rect">
+            <a:avLst/>
+          </a:prstGeom>
+          <a:noFill/>
+          <a:ln/>
+        </p:spPr>
+        <p:txBody>
+          <a:bodyPr wrap="square" lIns="0" tIns="0" rIns="0" bIns="0" rtlCol="0" anchor="ctr"/>
+          <a:lstStyle/>
+          <a:p>
+            <a:pPr marL="0" indent="0">
+              <a:buNone/>
+            </a:pPr>
+            <a:r>
+              <a:rPr lang="en-US" sz="1200" b="1" dirty="0">
+                <a:solidFill>
+                  <a:srgbClr val="1E293B"/>
+                </a:solidFill>
+                <a:latin typeface="Calibri" pitchFamily="34" charset="0"/>
+                <a:ea typeface="Calibri" pitchFamily="34" charset="-122"/>
+                <a:cs typeface="Calibri" pitchFamily="34" charset="-120"/>
+              </a:rPr>
+              <a:t>Architecture &amp; Design First</a:t>
+            </a:r>
+            <a:endParaRPr lang="en-US" sz="1200" dirty="0"/>
+          </a:p>
+        </p:txBody>
+      </p:sp>
+      <p:sp>
+        <p:nvSpPr>
+          <p:cNvPr id="9" name="Text 7"/>
+          <p:cNvSpPr/>
+          <p:nvPr/>
+        </p:nvSpPr>
+        <p:spPr>
+          <a:xfrm>
+            <a:off x="621792" y="1581912"/>
+            <a:ext cx="3749040" cy="457200"/>
+          </a:xfrm>
+          <a:prstGeom prst="rect">
+            <a:avLst/>
+          </a:prstGeom>
+          <a:noFill/>
+          <a:ln/>
+        </p:spPr>
+        <p:txBody>
+          <a:bodyPr wrap="square" lIns="0" tIns="0" rIns="0" bIns="0" rtlCol="0" anchor="ctr"/>
+          <a:lstStyle/>
+          <a:p>
+            <a:pPr marL="0" indent="0">
+              <a:buNone/>
+            </a:pPr>
+            <a:r>
               <a:rPr lang="en-US" sz="1000" dirty="0">
                 <a:solidFill>
-                  <a:srgbClr val="028090"/>
-                </a:solidFill>
-                <a:latin typeface="Calibri" pitchFamily="34" charset="0"/>
-                <a:ea typeface="Calibri" pitchFamily="34" charset="-122"/>
-                <a:cs typeface="Calibri" pitchFamily="34" charset="-120"/>
-              </a:rPr>
-              <a:t>· </a:t>
-            </a:r>
-            <a:r>
-              <a:rPr lang="en-US" sz="1000" dirty="0">
-                <a:solidFill>
-                  <a:srgbClr val="E8F4F8"/>
-                </a:solidFill>
-                <a:latin typeface="Calibri" pitchFamily="34" charset="0"/>
-                <a:ea typeface="Calibri" pitchFamily="34" charset="-122"/>
-                <a:cs typeface="Calibri" pitchFamily="34" charset="-120"/>
-              </a:rPr>
-              <a:t>Native hierarchical agent orchestration</a:t>
+                  <a:srgbClr val="475569"/>
+                </a:solidFill>
+                <a:latin typeface="Calibri" pitchFamily="34" charset="0"/>
+                <a:ea typeface="Calibri" pitchFamily="34" charset="-122"/>
+                <a:cs typeface="Calibri" pitchFamily="34" charset="-120"/>
+              </a:rPr>
+              <a:t>Started with AGENTS.md, CLAUDE.md, and a full C4-style architecture brief. System prompt design was the first artifact — not code.</a:t>
             </a:r>
             <a:endParaRPr lang="en-US" sz="1000" dirty="0"/>
           </a:p>
@@ -14137,126 +14407,26 @@
       </p:sp>
       <p:sp>
         <p:nvSpPr>
-          <p:cNvPr id="10" name="Text 7"/>
-          <p:cNvSpPr/>
-          <p:nvPr/>
-        </p:nvSpPr>
-        <p:spPr>
-          <a:xfrm>
-            <a:off x="548640" y="2971800"/>
-            <a:ext cx="1828800" cy="731520"/>
-          </a:xfrm>
-          <a:prstGeom prst="rect">
-            <a:avLst/>
-          </a:prstGeom>
-          <a:noFill/>
-          <a:ln/>
-        </p:spPr>
-        <p:txBody>
-          <a:bodyPr wrap="square" lIns="0" tIns="0" rIns="0" bIns="0" rtlCol="0" anchor="ctr"/>
-          <a:lstStyle/>
-          <a:p>
-            <a:pPr marL="0" indent="0">
-              <a:buNone/>
-            </a:pPr>
-            <a:r>
-              <a:rPr lang="en-US" sz="1000" dirty="0">
-                <a:solidFill>
-                  <a:srgbClr val="028090"/>
-                </a:solidFill>
-                <a:latin typeface="Calibri" pitchFamily="34" charset="0"/>
-                <a:ea typeface="Calibri" pitchFamily="34" charset="-122"/>
-                <a:cs typeface="Calibri" pitchFamily="34" charset="-120"/>
-              </a:rPr>
-              <a:t>· </a:t>
-            </a:r>
-            <a:r>
-              <a:rPr lang="en-US" sz="1000" dirty="0">
-                <a:solidFill>
-                  <a:srgbClr val="E8F4F8"/>
-                </a:solidFill>
-                <a:latin typeface="Calibri" pitchFamily="34" charset="0"/>
-                <a:ea typeface="Calibri" pitchFamily="34" charset="-122"/>
-                <a:cs typeface="Calibri" pitchFamily="34" charset="-120"/>
-              </a:rPr>
-              <a:t>transfer_to_agent() as the primary delegation primitive</a:t>
-            </a:r>
-            <a:endParaRPr lang="en-US" sz="1000" dirty="0"/>
-          </a:p>
-        </p:txBody>
-      </p:sp>
-      <p:sp>
-        <p:nvSpPr>
-          <p:cNvPr id="11" name="Text 8"/>
-          <p:cNvSpPr/>
-          <p:nvPr/>
-        </p:nvSpPr>
-        <p:spPr>
-          <a:xfrm>
-            <a:off x="548640" y="3794760"/>
-            <a:ext cx="1828800" cy="731520"/>
-          </a:xfrm>
-          <a:prstGeom prst="rect">
-            <a:avLst/>
-          </a:prstGeom>
-          <a:noFill/>
-          <a:ln/>
-        </p:spPr>
-        <p:txBody>
-          <a:bodyPr wrap="square" lIns="0" tIns="0" rIns="0" bIns="0" rtlCol="0" anchor="ctr"/>
-          <a:lstStyle/>
-          <a:p>
-            <a:pPr marL="0" indent="0">
-              <a:buNone/>
-            </a:pPr>
-            <a:r>
-              <a:rPr lang="en-US" sz="1000" dirty="0">
-                <a:solidFill>
-                  <a:srgbClr val="028090"/>
-                </a:solidFill>
-                <a:latin typeface="Calibri" pitchFamily="34" charset="0"/>
-                <a:ea typeface="Calibri" pitchFamily="34" charset="-122"/>
-                <a:cs typeface="Calibri" pitchFamily="34" charset="-120"/>
-              </a:rPr>
-              <a:t>· </a:t>
-            </a:r>
-            <a:r>
-              <a:rPr lang="en-US" sz="1000" dirty="0">
-                <a:solidFill>
-                  <a:srgbClr val="E8F4F8"/>
-                </a:solidFill>
-                <a:latin typeface="Calibri" pitchFamily="34" charset="0"/>
-                <a:ea typeface="Calibri" pitchFamily="34" charset="-122"/>
-                <a:cs typeface="Calibri" pitchFamily="34" charset="-120"/>
-              </a:rPr>
-              <a:t>Session state shared across all agents without custom sync</a:t>
-            </a:r>
-            <a:endParaRPr lang="en-US" sz="1000" dirty="0"/>
-          </a:p>
-        </p:txBody>
-      </p:sp>
-      <p:sp>
-        <p:nvSpPr>
-          <p:cNvPr id="12" name="Shape 9"/>
-          <p:cNvSpPr/>
-          <p:nvPr/>
-        </p:nvSpPr>
-        <p:spPr>
-          <a:xfrm>
-            <a:off x="2651760" y="914400"/>
-            <a:ext cx="2011680" cy="3931920"/>
-          </a:xfrm>
-          <a:prstGeom prst="rect">
-            <a:avLst/>
-          </a:prstGeom>
-          <a:solidFill>
-            <a:srgbClr val="102B5A"/>
+          <p:cNvPr id="10" name="Shape 8"/>
+          <p:cNvSpPr/>
+          <p:nvPr/>
+        </p:nvSpPr>
+        <p:spPr>
+          <a:xfrm>
+            <a:off x="457200" y="2240280"/>
+            <a:ext cx="4114800" cy="1188720"/>
+          </a:xfrm>
+          <a:prstGeom prst="rect">
+            <a:avLst/>
+          </a:prstGeom>
+          <a:solidFill>
+            <a:srgbClr val="FFFFFF"/>
           </a:solidFill>
           <a:ln/>
           <a:effectLst>
             <a:outerShdw blurRad="101600" dist="25400" dir="8100000" algn="bl" rotWithShape="0">
               <a:srgbClr val="000000">
-                <a:alpha val="30000"/>
+                <a:alpha val="10000"/>
               </a:srgbClr>
             </a:outerShdw>
           </a:effectLst>
@@ -14271,104 +14441,41 @@
       </p:sp>
       <p:sp>
         <p:nvSpPr>
-          <p:cNvPr id="13" name="Shape 10"/>
-          <p:cNvSpPr/>
-          <p:nvPr/>
-        </p:nvSpPr>
-        <p:spPr>
-          <a:xfrm>
-            <a:off x="2651760" y="914400"/>
-            <a:ext cx="2011680" cy="64008"/>
-          </a:xfrm>
-          <a:prstGeom prst="rect">
-            <a:avLst/>
-          </a:prstGeom>
-          <a:solidFill>
-            <a:srgbClr val="22D3A5"/>
-          </a:solidFill>
-          <a:ln/>
-        </p:spPr>
-        <p:txBody>
-          <a:bodyPr/>
-          <a:lstStyle/>
-          <a:p>
-            <a:endParaRPr lang="en-US"/>
-          </a:p>
-        </p:txBody>
-      </p:sp>
-      <p:pic>
-        <p:nvPicPr>
-          <p:cNvPr id="14" name="Image 1" descr="preencoded.png"/>
-          <p:cNvPicPr>
-            <a:picLocks noChangeAspect="1"/>
-          </p:cNvPicPr>
-          <p:nvPr/>
-        </p:nvPicPr>
-        <p:blipFill>
-          <a:blip r:embed="rId4"/>
-          <a:stretch>
-            <a:fillRect/>
-          </a:stretch>
-        </p:blipFill>
-        <p:spPr>
-          <a:xfrm>
-            <a:off x="3383280" y="1097280"/>
-            <a:ext cx="502920" cy="502920"/>
-          </a:xfrm>
-          <a:prstGeom prst="rect">
-            <a:avLst/>
-          </a:prstGeom>
-        </p:spPr>
-      </p:pic>
-      <p:sp>
-        <p:nvSpPr>
-          <p:cNvPr id="15" name="Text 11"/>
-          <p:cNvSpPr/>
-          <p:nvPr/>
-        </p:nvSpPr>
-        <p:spPr>
-          <a:xfrm>
-            <a:off x="2743200" y="1691640"/>
-            <a:ext cx="1828800" cy="365760"/>
-          </a:xfrm>
-          <a:prstGeom prst="rect">
-            <a:avLst/>
-          </a:prstGeom>
-          <a:noFill/>
-          <a:ln/>
-        </p:spPr>
-        <p:txBody>
-          <a:bodyPr wrap="square" lIns="0" tIns="0" rIns="0" bIns="0" rtlCol="0" anchor="ctr"/>
-          <a:lstStyle/>
-          <a:p>
-            <a:pPr marL="0" indent="0" algn="ctr">
-              <a:buNone/>
-            </a:pPr>
-            <a:r>
-              <a:rPr lang="en-US" sz="1300" b="1" dirty="0">
-                <a:solidFill>
-                  <a:srgbClr val="FFFFFF"/>
-                </a:solidFill>
-                <a:latin typeface="Calibri" pitchFamily="34" charset="0"/>
-                <a:ea typeface="Calibri" pitchFamily="34" charset="-122"/>
-                <a:cs typeface="Calibri" pitchFamily="34" charset="-120"/>
-              </a:rPr>
-              <a:t>Cable/MSO Domain</a:t>
-            </a:r>
-            <a:endParaRPr lang="en-US" sz="1300" dirty="0"/>
-          </a:p>
-        </p:txBody>
-      </p:sp>
-      <p:sp>
-        <p:nvSpPr>
-          <p:cNvPr id="16" name="Text 12"/>
-          <p:cNvSpPr/>
-          <p:nvPr/>
-        </p:nvSpPr>
-        <p:spPr>
-          <a:xfrm>
-            <a:off x="2743200" y="2148840"/>
-            <a:ext cx="1828800" cy="731520"/>
+          <p:cNvPr id="11" name="Shape 9"/>
+          <p:cNvSpPr/>
+          <p:nvPr/>
+        </p:nvSpPr>
+        <p:spPr>
+          <a:xfrm>
+            <a:off x="457200" y="2240280"/>
+            <a:ext cx="54864" cy="1188720"/>
+          </a:xfrm>
+          <a:prstGeom prst="rect">
+            <a:avLst/>
+          </a:prstGeom>
+          <a:solidFill>
+            <a:srgbClr val="00C2C7"/>
+          </a:solidFill>
+          <a:ln/>
+        </p:spPr>
+        <p:txBody>
+          <a:bodyPr/>
+          <a:lstStyle/>
+          <a:p>
+            <a:endParaRPr lang="en-US"/>
+          </a:p>
+        </p:txBody>
+      </p:sp>
+      <p:sp>
+        <p:nvSpPr>
+          <p:cNvPr id="12" name="Text 10"/>
+          <p:cNvSpPr/>
+          <p:nvPr/>
+        </p:nvSpPr>
+        <p:spPr>
+          <a:xfrm>
+            <a:off x="621792" y="2313432"/>
+            <a:ext cx="457200" cy="274320"/>
           </a:xfrm>
           <a:prstGeom prst="rect">
             <a:avLst/>
@@ -14384,26 +14491,93 @@
               <a:buNone/>
             </a:pPr>
             <a:r>
+              <a:rPr lang="en-US" sz="1600" b="1" dirty="0">
+                <a:solidFill>
+                  <a:srgbClr val="00C2C7"/>
+                </a:solidFill>
+                <a:latin typeface="Calibri" pitchFamily="34" charset="0"/>
+                <a:ea typeface="Calibri" pitchFamily="34" charset="-122"/>
+                <a:cs typeface="Calibri" pitchFamily="34" charset="-120"/>
+              </a:rPr>
+              <a:t>02</a:t>
+            </a:r>
+            <a:endParaRPr lang="en-US" sz="1600" dirty="0"/>
+          </a:p>
+        </p:txBody>
+      </p:sp>
+      <p:sp>
+        <p:nvSpPr>
+          <p:cNvPr id="13" name="Text 11"/>
+          <p:cNvSpPr/>
+          <p:nvPr/>
+        </p:nvSpPr>
+        <p:spPr>
+          <a:xfrm>
+            <a:off x="621792" y="2606040"/>
+            <a:ext cx="3749040" cy="274320"/>
+          </a:xfrm>
+          <a:prstGeom prst="rect">
+            <a:avLst/>
+          </a:prstGeom>
+          <a:noFill/>
+          <a:ln/>
+        </p:spPr>
+        <p:txBody>
+          <a:bodyPr wrap="square" lIns="0" tIns="0" rIns="0" bIns="0" rtlCol="0" anchor="ctr"/>
+          <a:lstStyle/>
+          <a:p>
+            <a:pPr marL="0" indent="0">
+              <a:buNone/>
+            </a:pPr>
+            <a:r>
+              <a:rPr lang="en-US" sz="1200" b="1" dirty="0">
+                <a:solidFill>
+                  <a:srgbClr val="1E293B"/>
+                </a:solidFill>
+                <a:latin typeface="Calibri" pitchFamily="34" charset="0"/>
+                <a:ea typeface="Calibri" pitchFamily="34" charset="-122"/>
+                <a:cs typeface="Calibri" pitchFamily="34" charset="-120"/>
+              </a:rPr>
+              <a:t>AI-Assisted Development</a:t>
+            </a:r>
+            <a:endParaRPr lang="en-US" sz="1200" dirty="0"/>
+          </a:p>
+        </p:txBody>
+      </p:sp>
+      <p:sp>
+        <p:nvSpPr>
+          <p:cNvPr id="14" name="Text 12"/>
+          <p:cNvSpPr/>
+          <p:nvPr/>
+        </p:nvSpPr>
+        <p:spPr>
+          <a:xfrm>
+            <a:off x="621792" y="2907792"/>
+            <a:ext cx="3749040" cy="457200"/>
+          </a:xfrm>
+          <a:prstGeom prst="rect">
+            <a:avLst/>
+          </a:prstGeom>
+          <a:noFill/>
+          <a:ln/>
+        </p:spPr>
+        <p:txBody>
+          <a:bodyPr wrap="square" lIns="0" tIns="0" rIns="0" bIns="0" rtlCol="0" anchor="ctr"/>
+          <a:lstStyle/>
+          <a:p>
+            <a:pPr marL="0" indent="0">
+              <a:buNone/>
+            </a:pPr>
+            <a:r>
               <a:rPr lang="en-US" sz="1000" dirty="0">
                 <a:solidFill>
-                  <a:srgbClr val="22D3A5"/>
-                </a:solidFill>
-                <a:latin typeface="Calibri" pitchFamily="34" charset="0"/>
-                <a:ea typeface="Calibri" pitchFamily="34" charset="-122"/>
-                <a:cs typeface="Calibri" pitchFamily="34" charset="-120"/>
-              </a:rPr>
-              <a:t>· </a:t>
-            </a:r>
-            <a:r>
-              <a:rPr lang="en-US" sz="1000" dirty="0">
-                <a:solidFill>
-                  <a:srgbClr val="E8F4F8"/>
-                </a:solidFill>
-                <a:latin typeface="Calibri" pitchFamily="34" charset="0"/>
-                <a:ea typeface="Calibri" pitchFamily="34" charset="-122"/>
-                <a:cs typeface="Calibri" pitchFamily="34" charset="-120"/>
-              </a:rPr>
-              <a:t>Real Comcast B2B product taxonomy mapped to agents</a:t>
+                  <a:srgbClr val="475569"/>
+                </a:solidFill>
+                <a:latin typeface="Calibri" pitchFamily="34" charset="0"/>
+                <a:ea typeface="Calibri" pitchFamily="34" charset="-122"/>
+                <a:cs typeface="Calibri" pitchFamily="34" charset="-120"/>
+              </a:rPr>
+              <a:t>Claude Code used for scaffolding agents, FastAPI routes, and React components. ~70% of boilerplate generated; 100% human-reviewed for ADK correctness.</a:t>
             </a:r>
             <a:endParaRPr lang="en-US" sz="1000" dirty="0"/>
           </a:p>
@@ -14411,126 +14585,26 @@
       </p:sp>
       <p:sp>
         <p:nvSpPr>
-          <p:cNvPr id="17" name="Text 13"/>
-          <p:cNvSpPr/>
-          <p:nvPr/>
-        </p:nvSpPr>
-        <p:spPr>
-          <a:xfrm>
-            <a:off x="2743200" y="2971800"/>
-            <a:ext cx="1828800" cy="731520"/>
-          </a:xfrm>
-          <a:prstGeom prst="rect">
-            <a:avLst/>
-          </a:prstGeom>
-          <a:noFill/>
-          <a:ln/>
-        </p:spPr>
-        <p:txBody>
-          <a:bodyPr wrap="square" lIns="0" tIns="0" rIns="0" bIns="0" rtlCol="0" anchor="ctr"/>
-          <a:lstStyle/>
-          <a:p>
-            <a:pPr marL="0" indent="0">
-              <a:buNone/>
-            </a:pPr>
-            <a:r>
-              <a:rPr lang="en-US" sz="1000" dirty="0">
-                <a:solidFill>
-                  <a:srgbClr val="22D3A5"/>
-                </a:solidFill>
-                <a:latin typeface="Calibri" pitchFamily="34" charset="0"/>
-                <a:ea typeface="Calibri" pitchFamily="34" charset="-122"/>
-                <a:cs typeface="Calibri" pitchFamily="34" charset="-120"/>
-              </a:rPr>
-              <a:t>· </a:t>
-            </a:r>
-            <a:r>
-              <a:rPr lang="en-US" sz="1000" dirty="0">
-                <a:solidFill>
-                  <a:srgbClr val="E8F4F8"/>
-                </a:solidFill>
-                <a:latin typeface="Calibri" pitchFamily="34" charset="0"/>
-                <a:ea typeface="Calibri" pitchFamily="34" charset="-122"/>
-                <a:cs typeface="Calibri" pitchFamily="34" charset="-120"/>
-              </a:rPr>
-              <a:t>Serviceability check mirrors actual BSS/OSS pre-sales flow</a:t>
-            </a:r>
-            <a:endParaRPr lang="en-US" sz="1000" dirty="0"/>
-          </a:p>
-        </p:txBody>
-      </p:sp>
-      <p:sp>
-        <p:nvSpPr>
-          <p:cNvPr id="18" name="Text 14"/>
-          <p:cNvSpPr/>
-          <p:nvPr/>
-        </p:nvSpPr>
-        <p:spPr>
-          <a:xfrm>
-            <a:off x="2743200" y="3794760"/>
-            <a:ext cx="1828800" cy="731520"/>
-          </a:xfrm>
-          <a:prstGeom prst="rect">
-            <a:avLst/>
-          </a:prstGeom>
-          <a:noFill/>
-          <a:ln/>
-        </p:spPr>
-        <p:txBody>
-          <a:bodyPr wrap="square" lIns="0" tIns="0" rIns="0" bIns="0" rtlCol="0" anchor="ctr"/>
-          <a:lstStyle/>
-          <a:p>
-            <a:pPr marL="0" indent="0">
-              <a:buNone/>
-            </a:pPr>
-            <a:r>
-              <a:rPr lang="en-US" sz="1000" dirty="0">
-                <a:solidFill>
-                  <a:srgbClr val="22D3A5"/>
-                </a:solidFill>
-                <a:latin typeface="Calibri" pitchFamily="34" charset="0"/>
-                <a:ea typeface="Calibri" pitchFamily="34" charset="-122"/>
-                <a:cs typeface="Calibri" pitchFamily="34" charset="-120"/>
-              </a:rPr>
-              <a:t>· </a:t>
-            </a:r>
-            <a:r>
-              <a:rPr lang="en-US" sz="1000" dirty="0">
-                <a:solidFill>
-                  <a:srgbClr val="E8F4F8"/>
-                </a:solidFill>
-                <a:latin typeface="Calibri" pitchFamily="34" charset="0"/>
-                <a:ea typeface="Calibri" pitchFamily="34" charset="-122"/>
-                <a:cs typeface="Calibri" pitchFamily="34" charset="-120"/>
-              </a:rPr>
-              <a:t>Pricing/discount logic mirrors real enterprise telco quoting</a:t>
-            </a:r>
-            <a:endParaRPr lang="en-US" sz="1000" dirty="0"/>
-          </a:p>
-        </p:txBody>
-      </p:sp>
-      <p:sp>
-        <p:nvSpPr>
-          <p:cNvPr id="19" name="Shape 15"/>
-          <p:cNvSpPr/>
-          <p:nvPr/>
-        </p:nvSpPr>
-        <p:spPr>
-          <a:xfrm>
-            <a:off x="4846320" y="914400"/>
-            <a:ext cx="2011680" cy="3931920"/>
-          </a:xfrm>
-          <a:prstGeom prst="rect">
-            <a:avLst/>
-          </a:prstGeom>
-          <a:solidFill>
-            <a:srgbClr val="102B5A"/>
+          <p:cNvPr id="15" name="Shape 13"/>
+          <p:cNvSpPr/>
+          <p:nvPr/>
+        </p:nvSpPr>
+        <p:spPr>
+          <a:xfrm>
+            <a:off x="457200" y="3566160"/>
+            <a:ext cx="4114800" cy="1188720"/>
+          </a:xfrm>
+          <a:prstGeom prst="rect">
+            <a:avLst/>
+          </a:prstGeom>
+          <a:solidFill>
+            <a:srgbClr val="FFFFFF"/>
           </a:solidFill>
           <a:ln/>
           <a:effectLst>
             <a:outerShdw blurRad="101600" dist="25400" dir="8100000" algn="bl" rotWithShape="0">
               <a:srgbClr val="000000">
-                <a:alpha val="30000"/>
+                <a:alpha val="10000"/>
               </a:srgbClr>
             </a:outerShdw>
           </a:effectLst>
@@ -14545,266 +14619,170 @@
       </p:sp>
       <p:sp>
         <p:nvSpPr>
-          <p:cNvPr id="20" name="Shape 16"/>
+          <p:cNvPr id="16" name="Shape 14"/>
+          <p:cNvSpPr/>
+          <p:nvPr/>
+        </p:nvSpPr>
+        <p:spPr>
+          <a:xfrm>
+            <a:off x="457200" y="3566160"/>
+            <a:ext cx="54864" cy="1188720"/>
+          </a:xfrm>
+          <a:prstGeom prst="rect">
+            <a:avLst/>
+          </a:prstGeom>
+          <a:solidFill>
+            <a:srgbClr val="00C2C7"/>
+          </a:solidFill>
+          <a:ln/>
+        </p:spPr>
+        <p:txBody>
+          <a:bodyPr/>
+          <a:lstStyle/>
+          <a:p>
+            <a:endParaRPr lang="en-US"/>
+          </a:p>
+        </p:txBody>
+      </p:sp>
+      <p:sp>
+        <p:nvSpPr>
+          <p:cNvPr id="17" name="Text 15"/>
+          <p:cNvSpPr/>
+          <p:nvPr/>
+        </p:nvSpPr>
+        <p:spPr>
+          <a:xfrm>
+            <a:off x="621792" y="3639312"/>
+            <a:ext cx="457200" cy="274320"/>
+          </a:xfrm>
+          <a:prstGeom prst="rect">
+            <a:avLst/>
+          </a:prstGeom>
+          <a:noFill/>
+          <a:ln/>
+        </p:spPr>
+        <p:txBody>
+          <a:bodyPr wrap="square" lIns="0" tIns="0" rIns="0" bIns="0" rtlCol="0" anchor="ctr"/>
+          <a:lstStyle/>
+          <a:p>
+            <a:pPr marL="0" indent="0">
+              <a:buNone/>
+            </a:pPr>
+            <a:r>
+              <a:rPr lang="en-US" sz="1600" b="1" dirty="0">
+                <a:solidFill>
+                  <a:srgbClr val="00C2C7"/>
+                </a:solidFill>
+                <a:latin typeface="Calibri" pitchFamily="34" charset="0"/>
+                <a:ea typeface="Calibri" pitchFamily="34" charset="-122"/>
+                <a:cs typeface="Calibri" pitchFamily="34" charset="-120"/>
+              </a:rPr>
+              <a:t>03</a:t>
+            </a:r>
+            <a:endParaRPr lang="en-US" sz="1600" dirty="0"/>
+          </a:p>
+        </p:txBody>
+      </p:sp>
+      <p:sp>
+        <p:nvSpPr>
+          <p:cNvPr id="18" name="Text 16"/>
+          <p:cNvSpPr/>
+          <p:nvPr/>
+        </p:nvSpPr>
+        <p:spPr>
+          <a:xfrm>
+            <a:off x="621792" y="3931920"/>
+            <a:ext cx="3749040" cy="274320"/>
+          </a:xfrm>
+          <a:prstGeom prst="rect">
+            <a:avLst/>
+          </a:prstGeom>
+          <a:noFill/>
+          <a:ln/>
+        </p:spPr>
+        <p:txBody>
+          <a:bodyPr wrap="square" lIns="0" tIns="0" rIns="0" bIns="0" rtlCol="0" anchor="ctr"/>
+          <a:lstStyle/>
+          <a:p>
+            <a:pPr marL="0" indent="0">
+              <a:buNone/>
+            </a:pPr>
+            <a:r>
+              <a:rPr lang="en-US" sz="1200" b="1" dirty="0">
+                <a:solidFill>
+                  <a:srgbClr val="1E293B"/>
+                </a:solidFill>
+                <a:latin typeface="Calibri" pitchFamily="34" charset="0"/>
+                <a:ea typeface="Calibri" pitchFamily="34" charset="-122"/>
+                <a:cs typeface="Calibri" pitchFamily="34" charset="-120"/>
+              </a:rPr>
+              <a:t>Human Judgment on Critical Paths</a:t>
+            </a:r>
+            <a:endParaRPr lang="en-US" sz="1200" dirty="0"/>
+          </a:p>
+        </p:txBody>
+      </p:sp>
+      <p:sp>
+        <p:nvSpPr>
+          <p:cNvPr id="19" name="Text 17"/>
+          <p:cNvSpPr/>
+          <p:nvPr/>
+        </p:nvSpPr>
+        <p:spPr>
+          <a:xfrm>
+            <a:off x="621792" y="4233672"/>
+            <a:ext cx="3749040" cy="457200"/>
+          </a:xfrm>
+          <a:prstGeom prst="rect">
+            <a:avLst/>
+          </a:prstGeom>
+          <a:noFill/>
+          <a:ln/>
+        </p:spPr>
+        <p:txBody>
+          <a:bodyPr wrap="square" lIns="0" tIns="0" rIns="0" bIns="0" rtlCol="0" anchor="ctr"/>
+          <a:lstStyle/>
+          <a:p>
+            <a:pPr marL="0" indent="0">
+              <a:buNone/>
+            </a:pPr>
+            <a:r>
+              <a:rPr lang="en-US" sz="1000" dirty="0">
+                <a:solidFill>
+                  <a:srgbClr val="475569"/>
+                </a:solidFill>
+                <a:latin typeface="Calibri" pitchFamily="34" charset="0"/>
+                <a:ea typeface="Calibri" pitchFamily="34" charset="-122"/>
+                <a:cs typeface="Calibri" pitchFamily="34" charset="-120"/>
+              </a:rPr>
+              <a:t>Agent routing logic, temperature config, tool contract schemas, and importlib isolation — all human-authored. AI doesn't know our ADK constraints.</a:t>
+            </a:r>
+            <a:endParaRPr lang="en-US" sz="1000" dirty="0"/>
+          </a:p>
+        </p:txBody>
+      </p:sp>
+      <p:sp>
+        <p:nvSpPr>
+          <p:cNvPr id="20" name="Shape 18"/>
           <p:cNvSpPr/>
           <p:nvPr/>
         </p:nvSpPr>
         <p:spPr>
           <a:xfrm>
             <a:off x="4846320" y="914400"/>
-            <a:ext cx="2011680" cy="64008"/>
-          </a:xfrm>
-          <a:prstGeom prst="rect">
-            <a:avLst/>
-          </a:prstGeom>
-          <a:solidFill>
-            <a:srgbClr val="F59E0B"/>
-          </a:solidFill>
-          <a:ln/>
-        </p:spPr>
-        <p:txBody>
-          <a:bodyPr/>
-          <a:lstStyle/>
-          <a:p>
-            <a:endParaRPr lang="en-US"/>
-          </a:p>
-        </p:txBody>
-      </p:sp>
-      <p:pic>
-        <p:nvPicPr>
-          <p:cNvPr id="21" name="Image 2" descr="preencoded.png"/>
-          <p:cNvPicPr>
-            <a:picLocks noChangeAspect="1"/>
-          </p:cNvPicPr>
-          <p:nvPr/>
-        </p:nvPicPr>
-        <p:blipFill>
-          <a:blip r:embed="rId5"/>
-          <a:stretch>
-            <a:fillRect/>
-          </a:stretch>
-        </p:blipFill>
-        <p:spPr>
-          <a:xfrm>
-            <a:off x="5577840" y="1097280"/>
-            <a:ext cx="502920" cy="502920"/>
-          </a:xfrm>
-          <a:prstGeom prst="rect">
-            <a:avLst/>
-          </a:prstGeom>
-        </p:spPr>
-      </p:pic>
-      <p:sp>
-        <p:nvSpPr>
-          <p:cNvPr id="22" name="Text 17"/>
-          <p:cNvSpPr/>
-          <p:nvPr/>
-        </p:nvSpPr>
-        <p:spPr>
-          <a:xfrm>
-            <a:off x="4937760" y="1691640"/>
-            <a:ext cx="1828800" cy="365760"/>
-          </a:xfrm>
-          <a:prstGeom prst="rect">
-            <a:avLst/>
-          </a:prstGeom>
-          <a:noFill/>
-          <a:ln/>
-        </p:spPr>
-        <p:txBody>
-          <a:bodyPr wrap="square" lIns="0" tIns="0" rIns="0" bIns="0" rtlCol="0" anchor="ctr"/>
-          <a:lstStyle/>
-          <a:p>
-            <a:pPr marL="0" indent="0" algn="ctr">
-              <a:buNone/>
-            </a:pPr>
-            <a:r>
-              <a:rPr lang="en-US" sz="1300" b="1" dirty="0">
-                <a:solidFill>
-                  <a:srgbClr val="FFFFFF"/>
-                </a:solidFill>
-                <a:latin typeface="Calibri" pitchFamily="34" charset="0"/>
-                <a:ea typeface="Calibri" pitchFamily="34" charset="-122"/>
-                <a:cs typeface="Calibri" pitchFamily="34" charset="-120"/>
-              </a:rPr>
-              <a:t>Academic Grounding</a:t>
-            </a:r>
-            <a:endParaRPr lang="en-US" sz="1300" dirty="0"/>
-          </a:p>
-        </p:txBody>
-      </p:sp>
-      <p:sp>
-        <p:nvSpPr>
-          <p:cNvPr id="23" name="Text 18"/>
-          <p:cNvSpPr/>
-          <p:nvPr/>
-        </p:nvSpPr>
-        <p:spPr>
-          <a:xfrm>
-            <a:off x="4937760" y="2148840"/>
-            <a:ext cx="1828800" cy="731520"/>
-          </a:xfrm>
-          <a:prstGeom prst="rect">
-            <a:avLst/>
-          </a:prstGeom>
-          <a:noFill/>
-          <a:ln/>
-        </p:spPr>
-        <p:txBody>
-          <a:bodyPr wrap="square" lIns="0" tIns="0" rIns="0" bIns="0" rtlCol="0" anchor="ctr"/>
-          <a:lstStyle/>
-          <a:p>
-            <a:pPr marL="0" indent="0">
-              <a:buNone/>
-            </a:pPr>
-            <a:r>
-              <a:rPr lang="en-US" sz="1000" dirty="0">
-                <a:solidFill>
-                  <a:srgbClr val="F59E0B"/>
-                </a:solidFill>
-                <a:latin typeface="Calibri" pitchFamily="34" charset="0"/>
-                <a:ea typeface="Calibri" pitchFamily="34" charset="-122"/>
-                <a:cs typeface="Calibri" pitchFamily="34" charset="-120"/>
-              </a:rPr>
-              <a:t>· </a:t>
-            </a:r>
-            <a:r>
-              <a:rPr lang="en-US" sz="1000" dirty="0">
-                <a:solidFill>
-                  <a:srgbClr val="E8F4F8"/>
-                </a:solidFill>
-                <a:latin typeface="Calibri" pitchFamily="34" charset="0"/>
-                <a:ea typeface="Calibri" pitchFamily="34" charset="-122"/>
-                <a:cs typeface="Calibri" pitchFamily="34" charset="-120"/>
-              </a:rPr>
-              <a:t>Multi-agent LLM orchestration literature (ReAct, AutoGPT lineage)</a:t>
-            </a:r>
-            <a:endParaRPr lang="en-US" sz="1000" dirty="0"/>
-          </a:p>
-        </p:txBody>
-      </p:sp>
-      <p:sp>
-        <p:nvSpPr>
-          <p:cNvPr id="24" name="Text 19"/>
-          <p:cNvSpPr/>
-          <p:nvPr/>
-        </p:nvSpPr>
-        <p:spPr>
-          <a:xfrm>
-            <a:off x="4937760" y="2971800"/>
-            <a:ext cx="1828800" cy="731520"/>
-          </a:xfrm>
-          <a:prstGeom prst="rect">
-            <a:avLst/>
-          </a:prstGeom>
-          <a:noFill/>
-          <a:ln/>
-        </p:spPr>
-        <p:txBody>
-          <a:bodyPr wrap="square" lIns="0" tIns="0" rIns="0" bIns="0" rtlCol="0" anchor="ctr"/>
-          <a:lstStyle/>
-          <a:p>
-            <a:pPr marL="0" indent="0">
-              <a:buNone/>
-            </a:pPr>
-            <a:r>
-              <a:rPr lang="en-US" sz="1000" dirty="0">
-                <a:solidFill>
-                  <a:srgbClr val="F59E0B"/>
-                </a:solidFill>
-                <a:latin typeface="Calibri" pitchFamily="34" charset="0"/>
-                <a:ea typeface="Calibri" pitchFamily="34" charset="-122"/>
-                <a:cs typeface="Calibri" pitchFamily="34" charset="-120"/>
-              </a:rPr>
-              <a:t>· </a:t>
-            </a:r>
-            <a:r>
-              <a:rPr lang="en-US" sz="1000" dirty="0">
-                <a:solidFill>
-                  <a:srgbClr val="E8F4F8"/>
-                </a:solidFill>
-                <a:latin typeface="Calibri" pitchFamily="34" charset="0"/>
-                <a:ea typeface="Calibri" pitchFamily="34" charset="-122"/>
-                <a:cs typeface="Calibri" pitchFamily="34" charset="-120"/>
-              </a:rPr>
-              <a:t>Hierarchical decomposition patterns for domain-specific agents</a:t>
-            </a:r>
-            <a:endParaRPr lang="en-US" sz="1000" dirty="0"/>
-          </a:p>
-        </p:txBody>
-      </p:sp>
-      <p:sp>
-        <p:nvSpPr>
-          <p:cNvPr id="25" name="Text 20"/>
-          <p:cNvSpPr/>
-          <p:nvPr/>
-        </p:nvSpPr>
-        <p:spPr>
-          <a:xfrm>
-            <a:off x="4937760" y="3794760"/>
-            <a:ext cx="1828800" cy="731520"/>
-          </a:xfrm>
-          <a:prstGeom prst="rect">
-            <a:avLst/>
-          </a:prstGeom>
-          <a:noFill/>
-          <a:ln/>
-        </p:spPr>
-        <p:txBody>
-          <a:bodyPr wrap="square" lIns="0" tIns="0" rIns="0" bIns="0" rtlCol="0" anchor="ctr"/>
-          <a:lstStyle/>
-          <a:p>
-            <a:pPr marL="0" indent="0">
-              <a:buNone/>
-            </a:pPr>
-            <a:r>
-              <a:rPr lang="en-US" sz="1000" dirty="0">
-                <a:solidFill>
-                  <a:srgbClr val="F59E0B"/>
-                </a:solidFill>
-                <a:latin typeface="Calibri" pitchFamily="34" charset="0"/>
-                <a:ea typeface="Calibri" pitchFamily="34" charset="-122"/>
-                <a:cs typeface="Calibri" pitchFamily="34" charset="-120"/>
-              </a:rPr>
-              <a:t>· </a:t>
-            </a:r>
-            <a:r>
-              <a:rPr lang="en-US" sz="1000" dirty="0">
-                <a:solidFill>
-                  <a:srgbClr val="E8F4F8"/>
-                </a:solidFill>
-                <a:latin typeface="Calibri" pitchFamily="34" charset="0"/>
-                <a:ea typeface="Calibri" pitchFamily="34" charset="-122"/>
-                <a:cs typeface="Calibri" pitchFamily="34" charset="-120"/>
-              </a:rPr>
-              <a:t>Tool-augmented LLM reasoning (Toolformer, ToolLLM)</a:t>
-            </a:r>
-            <a:endParaRPr lang="en-US" sz="1000" dirty="0"/>
-          </a:p>
-        </p:txBody>
-      </p:sp>
-      <p:sp>
-        <p:nvSpPr>
-          <p:cNvPr id="26" name="Shape 21"/>
-          <p:cNvSpPr/>
-          <p:nvPr/>
-        </p:nvSpPr>
-        <p:spPr>
-          <a:xfrm>
-            <a:off x="7040880" y="914400"/>
-            <a:ext cx="2011680" cy="3931920"/>
-          </a:xfrm>
-          <a:prstGeom prst="rect">
-            <a:avLst/>
-          </a:prstGeom>
-          <a:solidFill>
-            <a:srgbClr val="102B5A"/>
+            <a:ext cx="4114800" cy="1188720"/>
+          </a:xfrm>
+          <a:prstGeom prst="rect">
+            <a:avLst/>
+          </a:prstGeom>
+          <a:solidFill>
+            <a:srgbClr val="FFFFFF"/>
           </a:solidFill>
           <a:ln/>
           <a:effectLst>
             <a:outerShdw blurRad="101600" dist="25400" dir="8100000" algn="bl" rotWithShape="0">
               <a:srgbClr val="000000">
-                <a:alpha val="30000"/>
+                <a:alpha val="10000"/>
               </a:srgbClr>
             </a:outerShdw>
           </a:effectLst>
@@ -14819,104 +14797,41 @@
       </p:sp>
       <p:sp>
         <p:nvSpPr>
-          <p:cNvPr id="27" name="Shape 22"/>
-          <p:cNvSpPr/>
-          <p:nvPr/>
-        </p:nvSpPr>
-        <p:spPr>
-          <a:xfrm>
-            <a:off x="7040880" y="914400"/>
-            <a:ext cx="2011680" cy="64008"/>
-          </a:xfrm>
-          <a:prstGeom prst="rect">
-            <a:avLst/>
-          </a:prstGeom>
-          <a:solidFill>
-            <a:srgbClr val="C084FC"/>
-          </a:solidFill>
-          <a:ln/>
-        </p:spPr>
-        <p:txBody>
-          <a:bodyPr/>
-          <a:lstStyle/>
-          <a:p>
-            <a:endParaRPr lang="en-US"/>
-          </a:p>
-        </p:txBody>
-      </p:sp>
-      <p:pic>
-        <p:nvPicPr>
-          <p:cNvPr id="28" name="Image 3" descr="preencoded.png"/>
-          <p:cNvPicPr>
-            <a:picLocks noChangeAspect="1"/>
-          </p:cNvPicPr>
-          <p:nvPr/>
-        </p:nvPicPr>
-        <p:blipFill>
-          <a:blip r:embed="rId6"/>
-          <a:stretch>
-            <a:fillRect/>
-          </a:stretch>
-        </p:blipFill>
-        <p:spPr>
-          <a:xfrm>
-            <a:off x="7772400" y="1097280"/>
-            <a:ext cx="502920" cy="502920"/>
-          </a:xfrm>
-          <a:prstGeom prst="rect">
-            <a:avLst/>
-          </a:prstGeom>
-        </p:spPr>
-      </p:pic>
-      <p:sp>
-        <p:nvSpPr>
-          <p:cNvPr id="29" name="Text 23"/>
-          <p:cNvSpPr/>
-          <p:nvPr/>
-        </p:nvSpPr>
-        <p:spPr>
-          <a:xfrm>
-            <a:off x="7132320" y="1691640"/>
-            <a:ext cx="1828800" cy="365760"/>
-          </a:xfrm>
-          <a:prstGeom prst="rect">
-            <a:avLst/>
-          </a:prstGeom>
-          <a:noFill/>
-          <a:ln/>
-        </p:spPr>
-        <p:txBody>
-          <a:bodyPr wrap="square" lIns="0" tIns="0" rIns="0" bIns="0" rtlCol="0" anchor="ctr"/>
-          <a:lstStyle/>
-          <a:p>
-            <a:pPr marL="0" indent="0" algn="ctr">
-              <a:buNone/>
-            </a:pPr>
-            <a:r>
-              <a:rPr lang="en-US" sz="1300" b="1" dirty="0">
-                <a:solidFill>
-                  <a:srgbClr val="FFFFFF"/>
-                </a:solidFill>
-                <a:latin typeface="Calibri" pitchFamily="34" charset="0"/>
-                <a:ea typeface="Calibri" pitchFamily="34" charset="-122"/>
-                <a:cs typeface="Calibri" pitchFamily="34" charset="-120"/>
-              </a:rPr>
-              <a:t>Gemini API / ADK Shell</a:t>
-            </a:r>
-            <a:endParaRPr lang="en-US" sz="1300" dirty="0"/>
-          </a:p>
-        </p:txBody>
-      </p:sp>
-      <p:sp>
-        <p:nvSpPr>
-          <p:cNvPr id="30" name="Text 24"/>
-          <p:cNvSpPr/>
-          <p:nvPr/>
-        </p:nvSpPr>
-        <p:spPr>
-          <a:xfrm>
-            <a:off x="7132320" y="2148840"/>
-            <a:ext cx="1828800" cy="731520"/>
+          <p:cNvPr id="21" name="Shape 19"/>
+          <p:cNvSpPr/>
+          <p:nvPr/>
+        </p:nvSpPr>
+        <p:spPr>
+          <a:xfrm>
+            <a:off x="4846320" y="914400"/>
+            <a:ext cx="54864" cy="1188720"/>
+          </a:xfrm>
+          <a:prstGeom prst="rect">
+            <a:avLst/>
+          </a:prstGeom>
+          <a:solidFill>
+            <a:srgbClr val="00C2C7"/>
+          </a:solidFill>
+          <a:ln/>
+        </p:spPr>
+        <p:txBody>
+          <a:bodyPr/>
+          <a:lstStyle/>
+          <a:p>
+            <a:endParaRPr lang="en-US"/>
+          </a:p>
+        </p:txBody>
+      </p:sp>
+      <p:sp>
+        <p:nvSpPr>
+          <p:cNvPr id="22" name="Text 20"/>
+          <p:cNvSpPr/>
+          <p:nvPr/>
+        </p:nvSpPr>
+        <p:spPr>
+          <a:xfrm>
+            <a:off x="5010912" y="987552"/>
+            <a:ext cx="457200" cy="274320"/>
           </a:xfrm>
           <a:prstGeom prst="rect">
             <a:avLst/>
@@ -14932,26 +14847,271 @@
               <a:buNone/>
             </a:pPr>
             <a:r>
+              <a:rPr lang="en-US" sz="1600" b="1" dirty="0">
+                <a:solidFill>
+                  <a:srgbClr val="00C2C7"/>
+                </a:solidFill>
+                <a:latin typeface="Calibri" pitchFamily="34" charset="0"/>
+                <a:ea typeface="Calibri" pitchFamily="34" charset="-122"/>
+                <a:cs typeface="Calibri" pitchFamily="34" charset="-120"/>
+              </a:rPr>
+              <a:t>04</a:t>
+            </a:r>
+            <a:endParaRPr lang="en-US" sz="1600" dirty="0"/>
+          </a:p>
+        </p:txBody>
+      </p:sp>
+      <p:sp>
+        <p:nvSpPr>
+          <p:cNvPr id="23" name="Text 21"/>
+          <p:cNvSpPr/>
+          <p:nvPr/>
+        </p:nvSpPr>
+        <p:spPr>
+          <a:xfrm>
+            <a:off x="5010912" y="1280160"/>
+            <a:ext cx="3749040" cy="274320"/>
+          </a:xfrm>
+          <a:prstGeom prst="rect">
+            <a:avLst/>
+          </a:prstGeom>
+          <a:noFill/>
+          <a:ln/>
+        </p:spPr>
+        <p:txBody>
+          <a:bodyPr wrap="square" lIns="0" tIns="0" rIns="0" bIns="0" rtlCol="0" anchor="ctr"/>
+          <a:lstStyle/>
+          <a:p>
+            <a:pPr marL="0" indent="0">
+              <a:buNone/>
+            </a:pPr>
+            <a:r>
+              <a:rPr lang="en-US" sz="1200" b="1" dirty="0">
+                <a:solidFill>
+                  <a:srgbClr val="1E293B"/>
+                </a:solidFill>
+                <a:latin typeface="Calibri" pitchFamily="34" charset="0"/>
+                <a:ea typeface="Calibri" pitchFamily="34" charset="-122"/>
+                <a:cs typeface="Calibri" pitchFamily="34" charset="-120"/>
+              </a:rPr>
+              <a:t>GitHub for Coordination</a:t>
+            </a:r>
+            <a:endParaRPr lang="en-US" sz="1200" dirty="0"/>
+          </a:p>
+        </p:txBody>
+      </p:sp>
+      <p:sp>
+        <p:nvSpPr>
+          <p:cNvPr id="24" name="Text 22"/>
+          <p:cNvSpPr/>
+          <p:nvPr/>
+        </p:nvSpPr>
+        <p:spPr>
+          <a:xfrm>
+            <a:off x="5010912" y="1581912"/>
+            <a:ext cx="3749040" cy="457200"/>
+          </a:xfrm>
+          <a:prstGeom prst="rect">
+            <a:avLst/>
+          </a:prstGeom>
+          <a:noFill/>
+          <a:ln/>
+        </p:spPr>
+        <p:txBody>
+          <a:bodyPr wrap="square" lIns="0" tIns="0" rIns="0" bIns="0" rtlCol="0" anchor="ctr"/>
+          <a:lstStyle/>
+          <a:p>
+            <a:pPr marL="0" indent="0">
+              <a:buNone/>
+            </a:pPr>
+            <a:r>
               <a:rPr lang="en-US" sz="1000" dirty="0">
                 <a:solidFill>
-                  <a:srgbClr val="C084FC"/>
-                </a:solidFill>
-                <a:latin typeface="Calibri" pitchFamily="34" charset="0"/>
-                <a:ea typeface="Calibri" pitchFamily="34" charset="-122"/>
-                <a:cs typeface="Calibri" pitchFamily="34" charset="-120"/>
-              </a:rPr>
-              <a:t>· </a:t>
-            </a:r>
+                  <a:srgbClr val="475569"/>
+                </a:solidFill>
+                <a:latin typeface="Calibri" pitchFamily="34" charset="0"/>
+                <a:ea typeface="Calibri" pitchFamily="34" charset="-122"/>
+                <a:cs typeface="Calibri" pitchFamily="34" charset="-120"/>
+              </a:rPr>
+              <a:t>Feature branches per agent. PR-based code review across 4 team members. CLAUDE.md served as the AI context file for Claude Code in the repo.</a:t>
+            </a:r>
+            <a:endParaRPr lang="en-US" sz="1000" dirty="0"/>
+          </a:p>
+        </p:txBody>
+      </p:sp>
+      <p:sp>
+        <p:nvSpPr>
+          <p:cNvPr id="25" name="Shape 23"/>
+          <p:cNvSpPr/>
+          <p:nvPr/>
+        </p:nvSpPr>
+        <p:spPr>
+          <a:xfrm>
+            <a:off x="4846320" y="2240280"/>
+            <a:ext cx="4114800" cy="1188720"/>
+          </a:xfrm>
+          <a:prstGeom prst="rect">
+            <a:avLst/>
+          </a:prstGeom>
+          <a:solidFill>
+            <a:srgbClr val="FFFFFF"/>
+          </a:solidFill>
+          <a:ln/>
+          <a:effectLst>
+            <a:outerShdw blurRad="101600" dist="25400" dir="8100000" algn="bl" rotWithShape="0">
+              <a:srgbClr val="000000">
+                <a:alpha val="10000"/>
+              </a:srgbClr>
+            </a:outerShdw>
+          </a:effectLst>
+        </p:spPr>
+        <p:txBody>
+          <a:bodyPr/>
+          <a:lstStyle/>
+          <a:p>
+            <a:endParaRPr lang="en-US"/>
+          </a:p>
+        </p:txBody>
+      </p:sp>
+      <p:sp>
+        <p:nvSpPr>
+          <p:cNvPr id="26" name="Shape 24"/>
+          <p:cNvSpPr/>
+          <p:nvPr/>
+        </p:nvSpPr>
+        <p:spPr>
+          <a:xfrm>
+            <a:off x="4846320" y="2240280"/>
+            <a:ext cx="54864" cy="1188720"/>
+          </a:xfrm>
+          <a:prstGeom prst="rect">
+            <a:avLst/>
+          </a:prstGeom>
+          <a:solidFill>
+            <a:srgbClr val="00C2C7"/>
+          </a:solidFill>
+          <a:ln/>
+        </p:spPr>
+        <p:txBody>
+          <a:bodyPr/>
+          <a:lstStyle/>
+          <a:p>
+            <a:endParaRPr lang="en-US"/>
+          </a:p>
+        </p:txBody>
+      </p:sp>
+      <p:sp>
+        <p:nvSpPr>
+          <p:cNvPr id="27" name="Text 25"/>
+          <p:cNvSpPr/>
+          <p:nvPr/>
+        </p:nvSpPr>
+        <p:spPr>
+          <a:xfrm>
+            <a:off x="5010912" y="2313432"/>
+            <a:ext cx="457200" cy="274320"/>
+          </a:xfrm>
+          <a:prstGeom prst="rect">
+            <a:avLst/>
+          </a:prstGeom>
+          <a:noFill/>
+          <a:ln/>
+        </p:spPr>
+        <p:txBody>
+          <a:bodyPr wrap="square" lIns="0" tIns="0" rIns="0" bIns="0" rtlCol="0" anchor="ctr"/>
+          <a:lstStyle/>
+          <a:p>
+            <a:pPr marL="0" indent="0">
+              <a:buNone/>
+            </a:pPr>
+            <a:r>
+              <a:rPr lang="en-US" sz="1600" b="1" dirty="0">
+                <a:solidFill>
+                  <a:srgbClr val="00C2C7"/>
+                </a:solidFill>
+                <a:latin typeface="Calibri" pitchFamily="34" charset="0"/>
+                <a:ea typeface="Calibri" pitchFamily="34" charset="-122"/>
+                <a:cs typeface="Calibri" pitchFamily="34" charset="-120"/>
+              </a:rPr>
+              <a:t>05</a:t>
+            </a:r>
+            <a:endParaRPr lang="en-US" sz="1600" dirty="0"/>
+          </a:p>
+        </p:txBody>
+      </p:sp>
+      <p:sp>
+        <p:nvSpPr>
+          <p:cNvPr id="28" name="Text 26"/>
+          <p:cNvSpPr/>
+          <p:nvPr/>
+        </p:nvSpPr>
+        <p:spPr>
+          <a:xfrm>
+            <a:off x="5010912" y="2606040"/>
+            <a:ext cx="3749040" cy="274320"/>
+          </a:xfrm>
+          <a:prstGeom prst="rect">
+            <a:avLst/>
+          </a:prstGeom>
+          <a:noFill/>
+          <a:ln/>
+        </p:spPr>
+        <p:txBody>
+          <a:bodyPr wrap="square" lIns="0" tIns="0" rIns="0" bIns="0" rtlCol="0" anchor="ctr"/>
+          <a:lstStyle/>
+          <a:p>
+            <a:pPr marL="0" indent="0">
+              <a:buNone/>
+            </a:pPr>
+            <a:r>
+              <a:rPr lang="en-US" sz="1200" b="1" dirty="0">
+                <a:solidFill>
+                  <a:srgbClr val="1E293B"/>
+                </a:solidFill>
+                <a:latin typeface="Calibri" pitchFamily="34" charset="0"/>
+                <a:ea typeface="Calibri" pitchFamily="34" charset="-122"/>
+                <a:cs typeface="Calibri" pitchFamily="34" charset="-120"/>
+              </a:rPr>
+              <a:t>Iterative Agent Testing</a:t>
+            </a:r>
+            <a:endParaRPr lang="en-US" sz="1200" dirty="0"/>
+          </a:p>
+        </p:txBody>
+      </p:sp>
+      <p:sp>
+        <p:nvSpPr>
+          <p:cNvPr id="29" name="Text 27"/>
+          <p:cNvSpPr/>
+          <p:nvPr/>
+        </p:nvSpPr>
+        <p:spPr>
+          <a:xfrm>
+            <a:off x="5010912" y="2907792"/>
+            <a:ext cx="3749040" cy="457200"/>
+          </a:xfrm>
+          <a:prstGeom prst="rect">
+            <a:avLst/>
+          </a:prstGeom>
+          <a:noFill/>
+          <a:ln/>
+        </p:spPr>
+        <p:txBody>
+          <a:bodyPr wrap="square" lIns="0" tIns="0" rIns="0" bIns="0" rtlCol="0" anchor="ctr"/>
+          <a:lstStyle/>
+          <a:p>
+            <a:pPr marL="0" indent="0">
+              <a:buNone/>
+            </a:pPr>
             <a:r>
               <a:rPr lang="en-US" sz="1000" dirty="0">
                 <a:solidFill>
-                  <a:srgbClr val="E8F4F8"/>
-                </a:solidFill>
-                <a:latin typeface="Calibri" pitchFamily="34" charset="0"/>
-                <a:ea typeface="Calibri" pitchFamily="34" charset="-122"/>
-                <a:cs typeface="Calibri" pitchFamily="34" charset="-120"/>
-              </a:rPr>
-              <a:t>Gemini Flash for cost/speed tradeoff in production-grade use</a:t>
+                  <a:srgbClr val="475569"/>
+                </a:solidFill>
+                <a:latin typeface="Calibri" pitchFamily="34" charset="0"/>
+                <a:ea typeface="Calibri" pitchFamily="34" charset="-122"/>
+                <a:cs typeface="Calibri" pitchFamily="34" charset="-120"/>
+              </a:rPr>
+              <a:t>ADK dev server + per-agent log files in SuperAgent/logs/agents/. Each agent validated independently before integration into SuperAgent.</a:t>
             </a:r>
             <a:endParaRPr lang="en-US" sz="1000" dirty="0"/>
           </a:p>
@@ -14959,14 +15119,75 @@
       </p:sp>
       <p:sp>
         <p:nvSpPr>
-          <p:cNvPr id="31" name="Text 25"/>
-          <p:cNvSpPr/>
-          <p:nvPr/>
-        </p:nvSpPr>
-        <p:spPr>
-          <a:xfrm>
-            <a:off x="7132320" y="2971800"/>
-            <a:ext cx="1828800" cy="731520"/>
+          <p:cNvPr id="30" name="Shape 28"/>
+          <p:cNvSpPr/>
+          <p:nvPr/>
+        </p:nvSpPr>
+        <p:spPr>
+          <a:xfrm>
+            <a:off x="4846320" y="3566160"/>
+            <a:ext cx="4114800" cy="1188720"/>
+          </a:xfrm>
+          <a:prstGeom prst="rect">
+            <a:avLst/>
+          </a:prstGeom>
+          <a:solidFill>
+            <a:srgbClr val="FFFFFF"/>
+          </a:solidFill>
+          <a:ln/>
+          <a:effectLst>
+            <a:outerShdw blurRad="101600" dist="25400" dir="8100000" algn="bl" rotWithShape="0">
+              <a:srgbClr val="000000">
+                <a:alpha val="10000"/>
+              </a:srgbClr>
+            </a:outerShdw>
+          </a:effectLst>
+        </p:spPr>
+        <p:txBody>
+          <a:bodyPr/>
+          <a:lstStyle/>
+          <a:p>
+            <a:endParaRPr lang="en-US"/>
+          </a:p>
+        </p:txBody>
+      </p:sp>
+      <p:sp>
+        <p:nvSpPr>
+          <p:cNvPr id="31" name="Shape 29"/>
+          <p:cNvSpPr/>
+          <p:nvPr/>
+        </p:nvSpPr>
+        <p:spPr>
+          <a:xfrm>
+            <a:off x="4846320" y="3566160"/>
+            <a:ext cx="54864" cy="1188720"/>
+          </a:xfrm>
+          <a:prstGeom prst="rect">
+            <a:avLst/>
+          </a:prstGeom>
+          <a:solidFill>
+            <a:srgbClr val="00C2C7"/>
+          </a:solidFill>
+          <a:ln/>
+        </p:spPr>
+        <p:txBody>
+          <a:bodyPr/>
+          <a:lstStyle/>
+          <a:p>
+            <a:endParaRPr lang="en-US"/>
+          </a:p>
+        </p:txBody>
+      </p:sp>
+      <p:sp>
+        <p:nvSpPr>
+          <p:cNvPr id="32" name="Text 30"/>
+          <p:cNvSpPr/>
+          <p:nvPr/>
+        </p:nvSpPr>
+        <p:spPr>
+          <a:xfrm>
+            <a:off x="5010912" y="3639312"/>
+            <a:ext cx="457200" cy="274320"/>
           </a:xfrm>
           <a:prstGeom prst="rect">
             <a:avLst/>
@@ -14982,76 +15203,93 @@
               <a:buNone/>
             </a:pPr>
             <a:r>
+              <a:rPr lang="en-US" sz="1600" b="1" dirty="0">
+                <a:solidFill>
+                  <a:srgbClr val="00C2C7"/>
+                </a:solidFill>
+                <a:latin typeface="Calibri" pitchFamily="34" charset="0"/>
+                <a:ea typeface="Calibri" pitchFamily="34" charset="-122"/>
+                <a:cs typeface="Calibri" pitchFamily="34" charset="-120"/>
+              </a:rPr>
+              <a:t>06</a:t>
+            </a:r>
+            <a:endParaRPr lang="en-US" sz="1600" dirty="0"/>
+          </a:p>
+        </p:txBody>
+      </p:sp>
+      <p:sp>
+        <p:nvSpPr>
+          <p:cNvPr id="33" name="Text 31"/>
+          <p:cNvSpPr/>
+          <p:nvPr/>
+        </p:nvSpPr>
+        <p:spPr>
+          <a:xfrm>
+            <a:off x="5010912" y="3931920"/>
+            <a:ext cx="3749040" cy="274320"/>
+          </a:xfrm>
+          <a:prstGeom prst="rect">
+            <a:avLst/>
+          </a:prstGeom>
+          <a:noFill/>
+          <a:ln/>
+        </p:spPr>
+        <p:txBody>
+          <a:bodyPr wrap="square" lIns="0" tIns="0" rIns="0" bIns="0" rtlCol="0" anchor="ctr"/>
+          <a:lstStyle/>
+          <a:p>
+            <a:pPr marL="0" indent="0">
+              <a:buNone/>
+            </a:pPr>
+            <a:r>
+              <a:rPr lang="en-US" sz="1200" b="1" dirty="0">
+                <a:solidFill>
+                  <a:srgbClr val="1E293B"/>
+                </a:solidFill>
+                <a:latin typeface="Calibri" pitchFamily="34" charset="0"/>
+                <a:ea typeface="Calibri" pitchFamily="34" charset="-122"/>
+                <a:cs typeface="Calibri" pitchFamily="34" charset="-120"/>
+              </a:rPr>
+              <a:t>Spec-Driven Development</a:t>
+            </a:r>
+            <a:endParaRPr lang="en-US" sz="1200" dirty="0"/>
+          </a:p>
+        </p:txBody>
+      </p:sp>
+      <p:sp>
+        <p:nvSpPr>
+          <p:cNvPr id="34" name="Text 32"/>
+          <p:cNvSpPr/>
+          <p:nvPr/>
+        </p:nvSpPr>
+        <p:spPr>
+          <a:xfrm>
+            <a:off x="5010912" y="4233672"/>
+            <a:ext cx="3749040" cy="457200"/>
+          </a:xfrm>
+          <a:prstGeom prst="rect">
+            <a:avLst/>
+          </a:prstGeom>
+          <a:noFill/>
+          <a:ln/>
+        </p:spPr>
+        <p:txBody>
+          <a:bodyPr wrap="square" lIns="0" tIns="0" rIns="0" bIns="0" rtlCol="0" anchor="ctr"/>
+          <a:lstStyle/>
+          <a:p>
+            <a:pPr marL="0" indent="0">
+              <a:buNone/>
+            </a:pPr>
+            <a:r>
               <a:rPr lang="en-US" sz="1000" dirty="0">
                 <a:solidFill>
-                  <a:srgbClr val="C084FC"/>
-                </a:solidFill>
-                <a:latin typeface="Calibri" pitchFamily="34" charset="0"/>
-                <a:ea typeface="Calibri" pitchFamily="34" charset="-122"/>
-                <a:cs typeface="Calibri" pitchFamily="34" charset="-120"/>
-              </a:rPr>
-              <a:t>· </a:t>
-            </a:r>
-            <a:r>
-              <a:rPr lang="en-US" sz="1000" dirty="0">
-                <a:solidFill>
-                  <a:srgbClr val="E8F4F8"/>
-                </a:solidFill>
-                <a:latin typeface="Calibri" pitchFamily="34" charset="0"/>
-                <a:ea typeface="Calibri" pitchFamily="34" charset="-122"/>
-                <a:cs typeface="Calibri" pitchFamily="34" charset="-120"/>
-              </a:rPr>
-              <a:t>ADK shell provides CLI + dev server for rapid agent iteration</a:t>
-            </a:r>
-            <a:endParaRPr lang="en-US" sz="1000" dirty="0"/>
-          </a:p>
-        </p:txBody>
-      </p:sp>
-      <p:sp>
-        <p:nvSpPr>
-          <p:cNvPr id="32" name="Text 26"/>
-          <p:cNvSpPr/>
-          <p:nvPr/>
-        </p:nvSpPr>
-        <p:spPr>
-          <a:xfrm>
-            <a:off x="7132320" y="3794760"/>
-            <a:ext cx="1828800" cy="731520"/>
-          </a:xfrm>
-          <a:prstGeom prst="rect">
-            <a:avLst/>
-          </a:prstGeom>
-          <a:noFill/>
-          <a:ln/>
-        </p:spPr>
-        <p:txBody>
-          <a:bodyPr wrap="square" lIns="0" tIns="0" rIns="0" bIns="0" rtlCol="0" anchor="ctr"/>
-          <a:lstStyle/>
-          <a:p>
-            <a:pPr marL="0" indent="0">
-              <a:buNone/>
-            </a:pPr>
-            <a:r>
-              <a:rPr lang="en-US" sz="1000" dirty="0">
-                <a:solidFill>
-                  <a:srgbClr val="C084FC"/>
-                </a:solidFill>
-                <a:latin typeface="Calibri" pitchFamily="34" charset="0"/>
-                <a:ea typeface="Calibri" pitchFamily="34" charset="-122"/>
-                <a:cs typeface="Calibri" pitchFamily="34" charset="-120"/>
-              </a:rPr>
-              <a:t>· </a:t>
-            </a:r>
-            <a:r>
-              <a:rPr lang="en-US" sz="1000" dirty="0">
-                <a:solidFill>
-                  <a:srgbClr val="E8F4F8"/>
-                </a:solidFill>
-                <a:latin typeface="Calibri" pitchFamily="34" charset="0"/>
-                <a:ea typeface="Calibri" pitchFamily="34" charset="-122"/>
-                <a:cs typeface="Calibri" pitchFamily="34" charset="-120"/>
-              </a:rPr>
-              <a:t>Google AI Studio for prompt engineering and evals</a:t>
+                  <a:srgbClr val="475569"/>
+                </a:solidFill>
+                <a:latin typeface="Calibri" pitchFamily="34" charset="0"/>
+                <a:ea typeface="Calibri" pitchFamily="34" charset="-122"/>
+                <a:cs typeface="Calibri" pitchFamily="34" charset="-120"/>
+              </a:rPr>
+              <a:t>AGENTS.md and Openspec files defined tool contracts before implementation. Prevented agent drift — each agent knew exactly what to own and what not to touch.</a:t>
             </a:r>
             <a:endParaRPr lang="en-US" sz="1000" dirty="0"/>
           </a:p>

</xml_diff>